<commit_message>
Replace Product and Prototype track PPT templates with updated versions
Co-authored-by: Cursor <cursoragent@cursor.com>
</commit_message>
<xml_diff>
--- a/public/assets/Product_Track_Template.pptx
+++ b/public/assets/Product_Track_Template.pptx
@@ -19,19 +19,19 @@
   <p:notesSz cx="6858000" cy="9144000"/>
   <p:embeddedFontLst>
     <p:embeddedFont>
-      <p:font typeface="Instrument Serif Italics" charset="1" panose="00000000000000000000"/>
+      <p:font typeface="Helvetica World Bold" charset="1" panose="020B0800040000020004"/>
       <p:regular r:id="rId15"/>
     </p:embeddedFont>
     <p:embeddedFont>
-      <p:font typeface="Calibri (MS) Bold Italics" charset="1" panose="020F07020304040A0204"/>
+      <p:font typeface="League Spartan" charset="1" panose="00000800000000000000"/>
       <p:regular r:id="rId16"/>
     </p:embeddedFont>
     <p:embeddedFont>
-      <p:font typeface="Helvetica World Bold" charset="1" panose="020B0800040000020004"/>
+      <p:font typeface="Instrument Serif Italics" charset="1" panose="00000000000000000000"/>
       <p:regular r:id="rId17"/>
     </p:embeddedFont>
     <p:embeddedFont>
-      <p:font typeface="League Spartan" charset="1" panose="00000800000000000000"/>
+      <p:font typeface="Calibri (MS) Bold Italics" charset="1" panose="020F07020304040A0204"/>
       <p:regular r:id="rId18"/>
     </p:embeddedFont>
     <p:embeddedFont>
@@ -3104,8 +3104,8 @@
         </p:nvSpPr>
         <p:spPr>
           <a:xfrm flipH="false" flipV="false" rot="0">
-            <a:off x="-1585339" y="-720471"/>
-            <a:ext cx="21320424" cy="12006064"/>
+            <a:off x="-1753008" y="-5715"/>
+            <a:ext cx="20041008" cy="11285593"/>
           </a:xfrm>
           <a:custGeom>
             <a:avLst/>
@@ -3114,18 +3114,18 @@
             <a:cxnLst/>
             <a:rect r="r" b="b" t="t" l="l"/>
             <a:pathLst>
-              <a:path h="12006064" w="21320424">
+              <a:path h="11285593" w="20041008">
                 <a:moveTo>
                   <a:pt x="0" y="0"/>
                 </a:moveTo>
                 <a:lnTo>
-                  <a:pt x="21320425" y="0"/>
-                </a:lnTo>
-                <a:lnTo>
-                  <a:pt x="21320425" y="12006064"/>
-                </a:lnTo>
-                <a:lnTo>
-                  <a:pt x="0" y="12006064"/>
+                  <a:pt x="20041008" y="0"/>
+                </a:lnTo>
+                <a:lnTo>
+                  <a:pt x="20041008" y="11285593"/>
+                </a:lnTo>
+                <a:lnTo>
+                  <a:pt x="0" y="11285593"/>
                 </a:lnTo>
                 <a:lnTo>
                   <a:pt x="0" y="0"/>
@@ -3142,54 +3142,30 @@
           </a:blipFill>
         </p:spPr>
       </p:sp>
-      <p:sp>
-        <p:nvSpPr>
-          <p:cNvPr name="AutoShape 3" id="3"/>
-          <p:cNvSpPr/>
-          <p:nvPr/>
-        </p:nvSpPr>
-        <p:spPr>
-          <a:xfrm>
-            <a:off x="2372079" y="3636195"/>
-            <a:ext cx="7742727" cy="0"/>
-          </a:xfrm>
-          <a:prstGeom prst="line">
-            <a:avLst/>
-          </a:prstGeom>
-          <a:ln cap="flat" w="38100">
-            <a:solidFill>
-              <a:srgbClr val="B58FFF"/>
-            </a:solidFill>
-            <a:prstDash val="solid"/>
-            <a:headEnd type="none" len="sm" w="sm"/>
-            <a:tailEnd type="none" len="sm" w="sm"/>
-          </a:ln>
-        </p:spPr>
-      </p:sp>
       <p:grpSp>
         <p:nvGrpSpPr>
-          <p:cNvPr name="Group 4" id="4"/>
+          <p:cNvPr name="Group 3" id="3"/>
           <p:cNvGrpSpPr/>
           <p:nvPr/>
         </p:nvGrpSpPr>
         <p:grpSpPr>
           <a:xfrm rot="0">
-            <a:off x="2372079" y="3495545"/>
-            <a:ext cx="811282" cy="224150"/>
+            <a:off x="15072066" y="170381"/>
+            <a:ext cx="2815713" cy="1392732"/>
             <a:chOff x="0" y="0"/>
-            <a:chExt cx="213671" cy="59035"/>
+            <a:chExt cx="5638800" cy="2789110"/>
           </a:xfrm>
         </p:grpSpPr>
         <p:sp>
           <p:nvSpPr>
-            <p:cNvPr name="Freeform 5" id="5"/>
+            <p:cNvPr name="Freeform 4" id="4"/>
             <p:cNvSpPr/>
             <p:nvPr/>
           </p:nvSpPr>
           <p:spPr>
             <a:xfrm flipH="false" flipV="false" rot="0">
               <a:off x="0" y="0"/>
-              <a:ext cx="213671" cy="59035"/>
+              <a:ext cx="5638800" cy="2789174"/>
             </a:xfrm>
             <a:custGeom>
               <a:avLst/>
@@ -3198,206 +3174,198 @@
               <a:cxnLst/>
               <a:rect r="r" b="b" t="t" l="l"/>
               <a:pathLst>
-                <a:path h="59035" w="213671">
+                <a:path h="2789174" w="5638800">
                   <a:moveTo>
-                    <a:pt x="29518" y="0"/>
+                    <a:pt x="0" y="0"/>
                   </a:moveTo>
                   <a:lnTo>
-                    <a:pt x="184153" y="0"/>
-                  </a:lnTo>
-                  <a:cubicBezTo>
-                    <a:pt x="191982" y="0"/>
-                    <a:pt x="199490" y="3110"/>
-                    <a:pt x="205025" y="8646"/>
-                  </a:cubicBezTo>
-                  <a:cubicBezTo>
-                    <a:pt x="210561" y="14181"/>
-                    <a:pt x="213671" y="21689"/>
-                    <a:pt x="213671" y="29518"/>
-                  </a:cubicBezTo>
-                  <a:lnTo>
-                    <a:pt x="213671" y="29518"/>
-                  </a:lnTo>
-                  <a:cubicBezTo>
-                    <a:pt x="213671" y="37346"/>
-                    <a:pt x="210561" y="44854"/>
-                    <a:pt x="205025" y="50390"/>
-                  </a:cubicBezTo>
-                  <a:cubicBezTo>
-                    <a:pt x="199490" y="55926"/>
-                    <a:pt x="191982" y="59035"/>
-                    <a:pt x="184153" y="59035"/>
-                  </a:cubicBezTo>
-                  <a:lnTo>
-                    <a:pt x="29518" y="59035"/>
-                  </a:lnTo>
-                  <a:cubicBezTo>
-                    <a:pt x="21689" y="59035"/>
-                    <a:pt x="14181" y="55926"/>
-                    <a:pt x="8646" y="50390"/>
-                  </a:cubicBezTo>
-                  <a:cubicBezTo>
-                    <a:pt x="3110" y="44854"/>
-                    <a:pt x="0" y="37346"/>
-                    <a:pt x="0" y="29518"/>
-                  </a:cubicBezTo>
-                  <a:lnTo>
-                    <a:pt x="0" y="29518"/>
-                  </a:lnTo>
-                  <a:cubicBezTo>
-                    <a:pt x="0" y="21689"/>
-                    <a:pt x="3110" y="14181"/>
-                    <a:pt x="8646" y="8646"/>
-                  </a:cubicBezTo>
-                  <a:cubicBezTo>
-                    <a:pt x="14181" y="3110"/>
-                    <a:pt x="21689" y="0"/>
-                    <a:pt x="29518" y="0"/>
-                  </a:cubicBezTo>
+                    <a:pt x="5638800" y="0"/>
+                  </a:lnTo>
+                  <a:lnTo>
+                    <a:pt x="5638800" y="2789174"/>
+                  </a:lnTo>
+                  <a:lnTo>
+                    <a:pt x="0" y="2789174"/>
+                  </a:lnTo>
+                  <a:lnTo>
+                    <a:pt x="0" y="0"/>
+                  </a:lnTo>
                   <a:close/>
                 </a:path>
               </a:pathLst>
             </a:custGeom>
-            <a:solidFill>
-              <a:srgbClr val="7771DC"/>
-            </a:solidFill>
+            <a:blipFill>
+              <a:blip r:embed="rId3"/>
+              <a:stretch>
+                <a:fillRect l="0" t="-12469" r="0" b="2"/>
+              </a:stretch>
+            </a:blipFill>
           </p:spPr>
         </p:sp>
-        <p:sp>
-          <p:nvSpPr>
-            <p:cNvPr name="TextBox 6" id="6"/>
-            <p:cNvSpPr txBox="true"/>
-            <p:nvPr/>
-          </p:nvSpPr>
-          <p:spPr>
-            <a:xfrm>
-              <a:off x="0" y="-47625"/>
-              <a:ext cx="213671" cy="106660"/>
-            </a:xfrm>
-            <a:prstGeom prst="rect">
-              <a:avLst/>
-            </a:prstGeom>
-          </p:spPr>
-          <p:txBody>
-            <a:bodyPr anchor="ctr" rtlCol="false" tIns="50800" lIns="50800" bIns="50800" rIns="50800"/>
-            <a:lstStyle/>
-            <a:p>
-              <a:pPr algn="ctr">
-                <a:lnSpc>
-                  <a:spcPts val="3122"/>
-                </a:lnSpc>
-              </a:pPr>
-            </a:p>
-          </p:txBody>
-        </p:sp>
       </p:grpSp>
-      <p:sp>
-        <p:nvSpPr>
-          <p:cNvPr name="Freeform 7" id="7"/>
-          <p:cNvSpPr/>
-          <p:nvPr/>
-        </p:nvSpPr>
-        <p:spPr>
-          <a:xfrm flipH="false" flipV="false" rot="0">
-            <a:off x="9795206" y="3299915"/>
-            <a:ext cx="672561" cy="672561"/>
-          </a:xfrm>
-          <a:custGeom>
-            <a:avLst/>
-            <a:gdLst/>
-            <a:ahLst/>
-            <a:cxnLst/>
-            <a:rect r="r" b="b" t="t" l="l"/>
-            <a:pathLst>
-              <a:path h="672561" w="672561">
-                <a:moveTo>
-                  <a:pt x="0" y="0"/>
-                </a:moveTo>
-                <a:lnTo>
-                  <a:pt x="672560" y="0"/>
-                </a:lnTo>
-                <a:lnTo>
-                  <a:pt x="672560" y="672561"/>
-                </a:lnTo>
-                <a:lnTo>
-                  <a:pt x="0" y="672561"/>
-                </a:lnTo>
-                <a:lnTo>
-                  <a:pt x="0" y="0"/>
-                </a:lnTo>
-                <a:close/>
-              </a:path>
-            </a:pathLst>
-          </a:custGeom>
-          <a:blipFill>
-            <a:blip r:embed="rId3">
-              <a:extLst>
-                <a:ext uri="{96DAC541-7B7A-43D3-8B79-37D633B846F1}">
-                  <asvg:svgBlip xmlns:asvg="http://schemas.microsoft.com/office/drawing/2016/SVG/main" r:embed="rId4"/>
-                </a:ext>
-              </a:extLst>
-            </a:blip>
-            <a:stretch>
-              <a:fillRect l="0" t="0" r="0" b="0"/>
-            </a:stretch>
-          </a:blipFill>
-        </p:spPr>
-      </p:sp>
-      <p:sp>
-        <p:nvSpPr>
-          <p:cNvPr name="TextBox 8" id="8"/>
-          <p:cNvSpPr txBox="true"/>
-          <p:nvPr/>
-        </p:nvSpPr>
-        <p:spPr>
-          <a:xfrm rot="0">
-            <a:off x="14671072" y="510137"/>
-            <a:ext cx="1690640" cy="904199"/>
-          </a:xfrm>
-          <a:prstGeom prst="rect">
-            <a:avLst/>
-          </a:prstGeom>
-        </p:spPr>
-        <p:txBody>
-          <a:bodyPr anchor="t" rtlCol="false" tIns="0" lIns="0" bIns="0" rIns="0">
-            <a:spAutoFit/>
-          </a:bodyPr>
-          <a:lstStyle/>
-          <a:p>
-            <a:pPr algn="l">
-              <a:lnSpc>
-                <a:spcPts val="7279"/>
-              </a:lnSpc>
-            </a:pPr>
-            <a:r>
-              <a:rPr lang="en-US" sz="5199" i="true">
-                <a:solidFill>
-                  <a:srgbClr val="39ACA1"/>
-                </a:solidFill>
-                <a:latin typeface="Instrument Serif Italics"/>
-                <a:ea typeface="Instrument Serif Italics"/>
-                <a:cs typeface="Instrument Serif Italics"/>
-                <a:sym typeface="Instrument Serif Italics"/>
-              </a:rPr>
-              <a:t>Ignisia</a:t>
-            </a:r>
-          </a:p>
-        </p:txBody>
-      </p:sp>
       <p:grpSp>
         <p:nvGrpSpPr>
-          <p:cNvPr name="Group 9" id="9"/>
+          <p:cNvPr name="Group 5" id="5"/>
           <p:cNvGrpSpPr/>
           <p:nvPr/>
         </p:nvGrpSpPr>
         <p:grpSpPr>
           <a:xfrm rot="0">
-            <a:off x="13748509" y="515376"/>
-            <a:ext cx="923925" cy="981075"/>
+            <a:off x="5043230" y="2425034"/>
+            <a:ext cx="8095687" cy="672561"/>
             <a:chOff x="0" y="0"/>
-            <a:chExt cx="1231900" cy="1308100"/>
+            <a:chExt cx="10794249" cy="896747"/>
           </a:xfrm>
         </p:grpSpPr>
+        <p:sp>
+          <p:nvSpPr>
+            <p:cNvPr name="AutoShape 6" id="6"/>
+            <p:cNvSpPr/>
+            <p:nvPr/>
+          </p:nvSpPr>
+          <p:spPr>
+            <a:xfrm>
+              <a:off x="0" y="448374"/>
+              <a:ext cx="10323636" cy="0"/>
+            </a:xfrm>
+            <a:prstGeom prst="line">
+              <a:avLst/>
+            </a:prstGeom>
+            <a:ln cap="flat" w="50800">
+              <a:solidFill>
+                <a:srgbClr val="B58FFF"/>
+              </a:solidFill>
+              <a:prstDash val="solid"/>
+              <a:headEnd type="none" len="sm" w="sm"/>
+              <a:tailEnd type="none" len="sm" w="sm"/>
+            </a:ln>
+          </p:spPr>
+        </p:sp>
+        <p:grpSp>
+          <p:nvGrpSpPr>
+            <p:cNvPr name="Group 7" id="7"/>
+            <p:cNvGrpSpPr/>
+            <p:nvPr/>
+          </p:nvGrpSpPr>
+          <p:grpSpPr>
+            <a:xfrm rot="0">
+              <a:off x="0" y="260840"/>
+              <a:ext cx="1081709" cy="298867"/>
+              <a:chOff x="0" y="0"/>
+              <a:chExt cx="213671" cy="59035"/>
+            </a:xfrm>
+          </p:grpSpPr>
+          <p:sp>
+            <p:nvSpPr>
+              <p:cNvPr name="Freeform 8" id="8"/>
+              <p:cNvSpPr/>
+              <p:nvPr/>
+            </p:nvSpPr>
+            <p:spPr>
+              <a:xfrm flipH="false" flipV="false" rot="0">
+                <a:off x="0" y="0"/>
+                <a:ext cx="213671" cy="59035"/>
+              </a:xfrm>
+              <a:custGeom>
+                <a:avLst/>
+                <a:gdLst/>
+                <a:ahLst/>
+                <a:cxnLst/>
+                <a:rect r="r" b="b" t="t" l="l"/>
+                <a:pathLst>
+                  <a:path h="59035" w="213671">
+                    <a:moveTo>
+                      <a:pt x="29518" y="0"/>
+                    </a:moveTo>
+                    <a:lnTo>
+                      <a:pt x="184153" y="0"/>
+                    </a:lnTo>
+                    <a:cubicBezTo>
+                      <a:pt x="191982" y="0"/>
+                      <a:pt x="199490" y="3110"/>
+                      <a:pt x="205025" y="8646"/>
+                    </a:cubicBezTo>
+                    <a:cubicBezTo>
+                      <a:pt x="210561" y="14181"/>
+                      <a:pt x="213671" y="21689"/>
+                      <a:pt x="213671" y="29518"/>
+                    </a:cubicBezTo>
+                    <a:lnTo>
+                      <a:pt x="213671" y="29518"/>
+                    </a:lnTo>
+                    <a:cubicBezTo>
+                      <a:pt x="213671" y="37346"/>
+                      <a:pt x="210561" y="44854"/>
+                      <a:pt x="205025" y="50390"/>
+                    </a:cubicBezTo>
+                    <a:cubicBezTo>
+                      <a:pt x="199490" y="55926"/>
+                      <a:pt x="191982" y="59035"/>
+                      <a:pt x="184153" y="59035"/>
+                    </a:cubicBezTo>
+                    <a:lnTo>
+                      <a:pt x="29518" y="59035"/>
+                    </a:lnTo>
+                    <a:cubicBezTo>
+                      <a:pt x="21689" y="59035"/>
+                      <a:pt x="14181" y="55926"/>
+                      <a:pt x="8646" y="50390"/>
+                    </a:cubicBezTo>
+                    <a:cubicBezTo>
+                      <a:pt x="3110" y="44854"/>
+                      <a:pt x="0" y="37346"/>
+                      <a:pt x="0" y="29518"/>
+                    </a:cubicBezTo>
+                    <a:lnTo>
+                      <a:pt x="0" y="29518"/>
+                    </a:lnTo>
+                    <a:cubicBezTo>
+                      <a:pt x="0" y="21689"/>
+                      <a:pt x="3110" y="14181"/>
+                      <a:pt x="8646" y="8646"/>
+                    </a:cubicBezTo>
+                    <a:cubicBezTo>
+                      <a:pt x="14181" y="3110"/>
+                      <a:pt x="21689" y="0"/>
+                      <a:pt x="29518" y="0"/>
+                    </a:cubicBezTo>
+                    <a:close/>
+                  </a:path>
+                </a:pathLst>
+              </a:custGeom>
+              <a:solidFill>
+                <a:srgbClr val="7771DC"/>
+              </a:solidFill>
+            </p:spPr>
+          </p:sp>
+          <p:sp>
+            <p:nvSpPr>
+              <p:cNvPr name="TextBox 9" id="9"/>
+              <p:cNvSpPr txBox="true"/>
+              <p:nvPr/>
+            </p:nvSpPr>
+            <p:spPr>
+              <a:xfrm>
+                <a:off x="0" y="-47625"/>
+                <a:ext cx="213671" cy="106660"/>
+              </a:xfrm>
+              <a:prstGeom prst="rect">
+                <a:avLst/>
+              </a:prstGeom>
+            </p:spPr>
+            <p:txBody>
+              <a:bodyPr anchor="ctr" rtlCol="false" tIns="50800" lIns="50800" bIns="50800" rIns="50800"/>
+              <a:lstStyle/>
+              <a:p>
+                <a:pPr algn="ctr">
+                  <a:lnSpc>
+                    <a:spcPts val="3122"/>
+                  </a:lnSpc>
+                </a:pPr>
+              </a:p>
+            </p:txBody>
+          </p:sp>
+        </p:grpSp>
         <p:sp>
           <p:nvSpPr>
             <p:cNvPr name="Freeform 10" id="10"/>
@@ -3406,8 +3374,8 @@
           </p:nvSpPr>
           <p:spPr>
             <a:xfrm flipH="false" flipV="false" rot="0">
-              <a:off x="0" y="0"/>
-              <a:ext cx="1231900" cy="1308100"/>
+              <a:off x="9897502" y="0"/>
+              <a:ext cx="896747" cy="896747"/>
             </a:xfrm>
             <a:custGeom>
               <a:avLst/>
@@ -3416,18 +3384,18 @@
               <a:cxnLst/>
               <a:rect r="r" b="b" t="t" l="l"/>
               <a:pathLst>
-                <a:path h="1308100" w="1231900">
+                <a:path h="896747" w="896747">
                   <a:moveTo>
                     <a:pt x="0" y="0"/>
                   </a:moveTo>
                   <a:lnTo>
-                    <a:pt x="1231900" y="0"/>
-                  </a:lnTo>
-                  <a:lnTo>
-                    <a:pt x="1231900" y="1308100"/>
-                  </a:lnTo>
-                  <a:lnTo>
-                    <a:pt x="0" y="1308100"/>
+                    <a:pt x="896747" y="0"/>
+                  </a:lnTo>
+                  <a:lnTo>
+                    <a:pt x="896747" y="896747"/>
+                  </a:lnTo>
+                  <a:lnTo>
+                    <a:pt x="0" y="896747"/>
                   </a:lnTo>
                   <a:lnTo>
                     <a:pt x="0" y="0"/>
@@ -3437,486 +3405,10 @@
               </a:pathLst>
             </a:custGeom>
             <a:blipFill>
-              <a:blip r:embed="rId5"/>
-              <a:stretch>
-                <a:fillRect l="-6188" t="0" r="-141234" b="0"/>
-              </a:stretch>
-            </a:blipFill>
-          </p:spPr>
-        </p:sp>
-      </p:grpSp>
-      <p:sp>
-        <p:nvSpPr>
-          <p:cNvPr name="Freeform 11" id="11"/>
-          <p:cNvSpPr/>
-          <p:nvPr/>
-        </p:nvSpPr>
-        <p:spPr>
-          <a:xfrm flipH="false" flipV="false" rot="0">
-            <a:off x="2121691" y="314816"/>
-            <a:ext cx="2477152" cy="1375374"/>
-          </a:xfrm>
-          <a:custGeom>
-            <a:avLst/>
-            <a:gdLst/>
-            <a:ahLst/>
-            <a:cxnLst/>
-            <a:rect r="r" b="b" t="t" l="l"/>
-            <a:pathLst>
-              <a:path h="1375374" w="2477152">
-                <a:moveTo>
-                  <a:pt x="0" y="0"/>
-                </a:moveTo>
-                <a:lnTo>
-                  <a:pt x="2477152" y="0"/>
-                </a:lnTo>
-                <a:lnTo>
-                  <a:pt x="2477152" y="1375374"/>
-                </a:lnTo>
-                <a:lnTo>
-                  <a:pt x="0" y="1375374"/>
-                </a:lnTo>
-                <a:lnTo>
-                  <a:pt x="0" y="0"/>
-                </a:lnTo>
-                <a:close/>
-              </a:path>
-            </a:pathLst>
-          </a:custGeom>
-          <a:blipFill>
-            <a:blip r:embed="rId6"/>
-            <a:stretch>
-              <a:fillRect l="0" t="0" r="0" b="0"/>
-            </a:stretch>
-          </a:blipFill>
-        </p:spPr>
-      </p:sp>
-      <p:sp>
-        <p:nvSpPr>
-          <p:cNvPr name="Freeform 12" id="12"/>
-          <p:cNvSpPr/>
-          <p:nvPr/>
-        </p:nvSpPr>
-        <p:spPr>
-          <a:xfrm flipH="false" flipV="false" rot="0">
-            <a:off x="6853302" y="656842"/>
-            <a:ext cx="1745976" cy="753526"/>
-          </a:xfrm>
-          <a:custGeom>
-            <a:avLst/>
-            <a:gdLst/>
-            <a:ahLst/>
-            <a:cxnLst/>
-            <a:rect r="r" b="b" t="t" l="l"/>
-            <a:pathLst>
-              <a:path h="753526" w="1745976">
-                <a:moveTo>
-                  <a:pt x="0" y="0"/>
-                </a:moveTo>
-                <a:lnTo>
-                  <a:pt x="1745976" y="0"/>
-                </a:lnTo>
-                <a:lnTo>
-                  <a:pt x="1745976" y="753526"/>
-                </a:lnTo>
-                <a:lnTo>
-                  <a:pt x="0" y="753526"/>
-                </a:lnTo>
-                <a:lnTo>
-                  <a:pt x="0" y="0"/>
-                </a:lnTo>
-                <a:close/>
-              </a:path>
-            </a:pathLst>
-          </a:custGeom>
-          <a:blipFill>
-            <a:blip r:embed="rId7"/>
-            <a:stretch>
-              <a:fillRect l="0" t="0" r="0" b="0"/>
-            </a:stretch>
-          </a:blipFill>
-        </p:spPr>
-      </p:sp>
-      <p:sp>
-        <p:nvSpPr>
-          <p:cNvPr name="AutoShape 13" id="13"/>
-          <p:cNvSpPr/>
-          <p:nvPr/>
-        </p:nvSpPr>
-        <p:spPr>
-          <a:xfrm flipV="true">
-            <a:off x="4636943" y="554828"/>
-            <a:ext cx="0" cy="857250"/>
-          </a:xfrm>
-          <a:prstGeom prst="line">
-            <a:avLst/>
-          </a:prstGeom>
-          <a:ln cap="flat" w="38100">
-            <a:solidFill>
-              <a:srgbClr val="B58FFF"/>
-            </a:solidFill>
-            <a:prstDash val="solid"/>
-            <a:headEnd type="none" len="sm" w="sm"/>
-            <a:tailEnd type="none" len="sm" w="sm"/>
-          </a:ln>
-        </p:spPr>
-      </p:sp>
-      <p:sp>
-        <p:nvSpPr>
-          <p:cNvPr name="AutoShape 14" id="14"/>
-          <p:cNvSpPr/>
-          <p:nvPr/>
-        </p:nvSpPr>
-        <p:spPr>
-          <a:xfrm flipV="true">
-            <a:off x="6514651" y="554828"/>
-            <a:ext cx="0" cy="857250"/>
-          </a:xfrm>
-          <a:prstGeom prst="line">
-            <a:avLst/>
-          </a:prstGeom>
-          <a:ln cap="flat" w="38100">
-            <a:solidFill>
-              <a:srgbClr val="B58FFF"/>
-            </a:solidFill>
-            <a:prstDash val="solid"/>
-            <a:headEnd type="none" len="sm" w="sm"/>
-            <a:tailEnd type="none" len="sm" w="sm"/>
-          </a:ln>
-        </p:spPr>
-      </p:sp>
-      <p:sp>
-        <p:nvSpPr>
-          <p:cNvPr name="AutoShape 15" id="15"/>
-          <p:cNvSpPr/>
-          <p:nvPr/>
-        </p:nvSpPr>
-        <p:spPr>
-          <a:xfrm flipV="true">
-            <a:off x="8780253" y="553118"/>
-            <a:ext cx="0" cy="857250"/>
-          </a:xfrm>
-          <a:prstGeom prst="line">
-            <a:avLst/>
-          </a:prstGeom>
-          <a:ln cap="flat" w="38100">
-            <a:solidFill>
-              <a:srgbClr val="B58FFF"/>
-            </a:solidFill>
-            <a:prstDash val="solid"/>
-            <a:headEnd type="none" len="sm" w="sm"/>
-            <a:tailEnd type="none" len="sm" w="sm"/>
-          </a:ln>
-        </p:spPr>
-      </p:sp>
-      <p:sp>
-        <p:nvSpPr>
-          <p:cNvPr name="AutoShape 16" id="16"/>
-          <p:cNvSpPr/>
-          <p:nvPr/>
-        </p:nvSpPr>
-        <p:spPr>
-          <a:xfrm flipV="true">
-            <a:off x="11045854" y="551409"/>
-            <a:ext cx="0" cy="857250"/>
-          </a:xfrm>
-          <a:prstGeom prst="line">
-            <a:avLst/>
-          </a:prstGeom>
-          <a:ln cap="flat" w="38100">
-            <a:solidFill>
-              <a:srgbClr val="B58FFF"/>
-            </a:solidFill>
-            <a:prstDash val="solid"/>
-            <a:headEnd type="none" len="sm" w="sm"/>
-            <a:tailEnd type="none" len="sm" w="sm"/>
-          </a:ln>
-        </p:spPr>
-      </p:sp>
-      <p:sp>
-        <p:nvSpPr>
-          <p:cNvPr name="AutoShape 17" id="17"/>
-          <p:cNvSpPr/>
-          <p:nvPr/>
-        </p:nvSpPr>
-        <p:spPr>
-          <a:xfrm flipV="true">
-            <a:off x="13311456" y="549699"/>
-            <a:ext cx="0" cy="857250"/>
-          </a:xfrm>
-          <a:prstGeom prst="line">
-            <a:avLst/>
-          </a:prstGeom>
-          <a:ln cap="flat" w="38100">
-            <a:solidFill>
-              <a:srgbClr val="B58FFF"/>
-            </a:solidFill>
-            <a:prstDash val="solid"/>
-            <a:headEnd type="none" len="sm" w="sm"/>
-            <a:tailEnd type="none" len="sm" w="sm"/>
-          </a:ln>
-        </p:spPr>
-      </p:sp>
-      <p:sp>
-        <p:nvSpPr>
-          <p:cNvPr name="Freeform 18" id="18"/>
-          <p:cNvSpPr/>
-          <p:nvPr/>
-        </p:nvSpPr>
-        <p:spPr>
-          <a:xfrm flipH="false" flipV="false" rot="0">
-            <a:off x="9476586" y="656842"/>
-            <a:ext cx="872935" cy="755236"/>
-          </a:xfrm>
-          <a:custGeom>
-            <a:avLst/>
-            <a:gdLst/>
-            <a:ahLst/>
-            <a:cxnLst/>
-            <a:rect r="r" b="b" t="t" l="l"/>
-            <a:pathLst>
-              <a:path h="755236" w="872935">
-                <a:moveTo>
-                  <a:pt x="0" y="0"/>
-                </a:moveTo>
-                <a:lnTo>
-                  <a:pt x="872935" y="0"/>
-                </a:lnTo>
-                <a:lnTo>
-                  <a:pt x="872935" y="755236"/>
-                </a:lnTo>
-                <a:lnTo>
-                  <a:pt x="0" y="755236"/>
-                </a:lnTo>
-                <a:lnTo>
-                  <a:pt x="0" y="0"/>
-                </a:lnTo>
-                <a:close/>
-              </a:path>
-            </a:pathLst>
-          </a:custGeom>
-          <a:blipFill>
-            <a:blip r:embed="rId8"/>
-            <a:stretch>
-              <a:fillRect l="0" t="0" r="0" b="0"/>
-            </a:stretch>
-          </a:blipFill>
-        </p:spPr>
-      </p:sp>
-      <p:sp>
-        <p:nvSpPr>
-          <p:cNvPr name="Freeform 19" id="19"/>
-          <p:cNvSpPr/>
-          <p:nvPr/>
-        </p:nvSpPr>
-        <p:spPr>
-          <a:xfrm flipH="false" flipV="false" rot="0">
-            <a:off x="11149480" y="554828"/>
-            <a:ext cx="2058350" cy="876300"/>
-          </a:xfrm>
-          <a:custGeom>
-            <a:avLst/>
-            <a:gdLst/>
-            <a:ahLst/>
-            <a:cxnLst/>
-            <a:rect r="r" b="b" t="t" l="l"/>
-            <a:pathLst>
-              <a:path h="876300" w="2058350">
-                <a:moveTo>
-                  <a:pt x="0" y="0"/>
-                </a:moveTo>
-                <a:lnTo>
-                  <a:pt x="2058350" y="0"/>
-                </a:lnTo>
-                <a:lnTo>
-                  <a:pt x="2058350" y="876300"/>
-                </a:lnTo>
-                <a:lnTo>
-                  <a:pt x="0" y="876300"/>
-                </a:lnTo>
-                <a:lnTo>
-                  <a:pt x="0" y="0"/>
-                </a:lnTo>
-                <a:close/>
-              </a:path>
-            </a:pathLst>
-          </a:custGeom>
-          <a:blipFill>
-            <a:blip r:embed="rId9"/>
-            <a:stretch>
-              <a:fillRect l="0" t="-33158" r="0" b="-43061"/>
-            </a:stretch>
-          </a:blipFill>
-        </p:spPr>
-      </p:sp>
-      <p:sp>
-        <p:nvSpPr>
-          <p:cNvPr name="TextBox 20" id="20"/>
-          <p:cNvSpPr txBox="true"/>
-          <p:nvPr/>
-        </p:nvSpPr>
-        <p:spPr>
-          <a:xfrm rot="0">
-            <a:off x="15026050" y="1333506"/>
-            <a:ext cx="966235" cy="152629"/>
-          </a:xfrm>
-          <a:prstGeom prst="rect">
-            <a:avLst/>
-          </a:prstGeom>
-        </p:spPr>
-        <p:txBody>
-          <a:bodyPr anchor="t" rtlCol="false" tIns="0" lIns="0" bIns="0" rIns="0">
-            <a:spAutoFit/>
-          </a:bodyPr>
-          <a:lstStyle/>
-          <a:p>
-            <a:pPr algn="l">
-              <a:lnSpc>
-                <a:spcPts val="1097"/>
-              </a:lnSpc>
-            </a:pPr>
-            <a:r>
-              <a:rPr lang="en-US" b="true" sz="784" i="true">
-                <a:solidFill>
-                  <a:srgbClr val="000000"/>
-                </a:solidFill>
-                <a:latin typeface="Calibri (MS) Bold Italics"/>
-                <a:ea typeface="Calibri (MS) Bold Italics"/>
-                <a:cs typeface="Calibri (MS) Bold Italics"/>
-                <a:sym typeface="Calibri (MS) Bold Italics"/>
-              </a:rPr>
-              <a:t>THINK. </a:t>
-            </a:r>
-            <a:r>
-              <a:rPr lang="en-US" b="true" sz="784" i="true">
-                <a:solidFill>
-                  <a:srgbClr val="39ACA1"/>
-                </a:solidFill>
-                <a:latin typeface="Calibri (MS) Bold Italics"/>
-                <a:ea typeface="Calibri (MS) Bold Italics"/>
-                <a:cs typeface="Calibri (MS) Bold Italics"/>
-                <a:sym typeface="Calibri (MS) Bold Italics"/>
-              </a:rPr>
-              <a:t>BUILD.</a:t>
-            </a:r>
-            <a:r>
-              <a:rPr lang="en-US" b="true" sz="784" i="true">
-                <a:solidFill>
-                  <a:srgbClr val="000000"/>
-                </a:solidFill>
-                <a:latin typeface="Calibri (MS) Bold Italics"/>
-                <a:ea typeface="Calibri (MS) Bold Italics"/>
-                <a:cs typeface="Calibri (MS) Bold Italics"/>
-                <a:sym typeface="Calibri (MS) Bold Italics"/>
-              </a:rPr>
-              <a:t> EVOLVE.</a:t>
-            </a:r>
-          </a:p>
-        </p:txBody>
-      </p:sp>
-      <p:sp>
-        <p:nvSpPr>
-          <p:cNvPr name="Freeform 21" id="21"/>
-          <p:cNvSpPr/>
-          <p:nvPr/>
-        </p:nvSpPr>
-        <p:spPr>
-          <a:xfrm flipH="false" flipV="false" rot="0">
-            <a:off x="4451528" y="-100151"/>
-            <a:ext cx="2114191" cy="2114191"/>
-          </a:xfrm>
-          <a:custGeom>
-            <a:avLst/>
-            <a:gdLst/>
-            <a:ahLst/>
-            <a:cxnLst/>
-            <a:rect r="r" b="b" t="t" l="l"/>
-            <a:pathLst>
-              <a:path h="2114191" w="2114191">
-                <a:moveTo>
-                  <a:pt x="0" y="0"/>
-                </a:moveTo>
-                <a:lnTo>
-                  <a:pt x="2114191" y="0"/>
-                </a:lnTo>
-                <a:lnTo>
-                  <a:pt x="2114191" y="2114191"/>
-                </a:lnTo>
-                <a:lnTo>
-                  <a:pt x="0" y="2114191"/>
-                </a:lnTo>
-                <a:lnTo>
-                  <a:pt x="0" y="0"/>
-                </a:lnTo>
-                <a:close/>
-              </a:path>
-            </a:pathLst>
-          </a:custGeom>
-          <a:blipFill>
-            <a:blip r:embed="rId10"/>
-            <a:stretch>
-              <a:fillRect l="0" t="0" r="0" b="0"/>
-            </a:stretch>
-          </a:blipFill>
-        </p:spPr>
-      </p:sp>
-      <p:grpSp>
-        <p:nvGrpSpPr>
-          <p:cNvPr name="Group 22" id="22"/>
-          <p:cNvGrpSpPr/>
-          <p:nvPr/>
-        </p:nvGrpSpPr>
-        <p:grpSpPr>
-          <a:xfrm rot="0">
-            <a:off x="2400654" y="4658310"/>
-            <a:ext cx="11057340" cy="3717285"/>
-            <a:chOff x="0" y="0"/>
-            <a:chExt cx="14743120" cy="4956381"/>
-          </a:xfrm>
-        </p:grpSpPr>
-        <p:sp>
-          <p:nvSpPr>
-            <p:cNvPr name="Freeform 23" id="23"/>
-            <p:cNvSpPr/>
-            <p:nvPr/>
-          </p:nvSpPr>
-          <p:spPr>
-            <a:xfrm flipH="false" flipV="false" rot="0">
-              <a:off x="14343084" y="2115740"/>
-              <a:ext cx="380667" cy="380667"/>
-            </a:xfrm>
-            <a:custGeom>
-              <a:avLst/>
-              <a:gdLst/>
-              <a:ahLst/>
-              <a:cxnLst/>
-              <a:rect r="r" b="b" t="t" l="l"/>
-              <a:pathLst>
-                <a:path h="380667" w="380667">
-                  <a:moveTo>
-                    <a:pt x="0" y="0"/>
-                  </a:moveTo>
-                  <a:lnTo>
-                    <a:pt x="380667" y="0"/>
-                  </a:lnTo>
-                  <a:lnTo>
-                    <a:pt x="380667" y="380667"/>
-                  </a:lnTo>
-                  <a:lnTo>
-                    <a:pt x="0" y="380667"/>
-                  </a:lnTo>
-                  <a:lnTo>
-                    <a:pt x="0" y="0"/>
-                  </a:lnTo>
-                  <a:close/>
-                </a:path>
-              </a:pathLst>
-            </a:custGeom>
-            <a:blipFill>
-              <a:blip r:embed="rId11">
+              <a:blip r:embed="rId4">
                 <a:extLst>
                   <a:ext uri="{96DAC541-7B7A-43D3-8B79-37D633B846F1}">
-                    <asvg:svgBlip xmlns:asvg="http://schemas.microsoft.com/office/drawing/2016/SVG/main" r:embed="rId12"/>
+                    <asvg:svgBlip xmlns:asvg="http://schemas.microsoft.com/office/drawing/2016/SVG/main" r:embed="rId5"/>
                   </a:ext>
                 </a:extLst>
               </a:blip>
@@ -3926,165 +3418,232 @@
             </a:blipFill>
           </p:spPr>
         </p:sp>
-        <p:sp>
-          <p:nvSpPr>
-            <p:cNvPr name="Freeform 24" id="24"/>
-            <p:cNvSpPr/>
-            <p:nvPr/>
-          </p:nvSpPr>
-          <p:spPr>
-            <a:xfrm flipH="false" flipV="false" rot="0">
-              <a:off x="14323714" y="3345727"/>
-              <a:ext cx="380667" cy="380667"/>
-            </a:xfrm>
-            <a:custGeom>
-              <a:avLst/>
-              <a:gdLst/>
-              <a:ahLst/>
-              <a:cxnLst/>
-              <a:rect r="r" b="b" t="t" l="l"/>
-              <a:pathLst>
-                <a:path h="380667" w="380667">
-                  <a:moveTo>
-                    <a:pt x="0" y="0"/>
-                  </a:moveTo>
-                  <a:lnTo>
-                    <a:pt x="380667" y="0"/>
-                  </a:lnTo>
-                  <a:lnTo>
-                    <a:pt x="380667" y="380667"/>
-                  </a:lnTo>
-                  <a:lnTo>
-                    <a:pt x="0" y="380667"/>
-                  </a:lnTo>
-                  <a:lnTo>
-                    <a:pt x="0" y="0"/>
-                  </a:lnTo>
-                  <a:close/>
-                </a:path>
-              </a:pathLst>
-            </a:custGeom>
-            <a:blipFill>
-              <a:blip r:embed="rId11">
-                <a:extLst>
-                  <a:ext uri="{96DAC541-7B7A-43D3-8B79-37D633B846F1}">
-                    <asvg:svgBlip xmlns:asvg="http://schemas.microsoft.com/office/drawing/2016/SVG/main" r:embed="rId12"/>
-                  </a:ext>
-                </a:extLst>
-              </a:blip>
-              <a:stretch>
-                <a:fillRect l="0" t="0" r="0" b="0"/>
-              </a:stretch>
-            </a:blipFill>
-          </p:spPr>
-        </p:sp>
-        <p:sp>
-          <p:nvSpPr>
-            <p:cNvPr name="Freeform 25" id="25"/>
-            <p:cNvSpPr/>
-            <p:nvPr/>
-          </p:nvSpPr>
-          <p:spPr>
-            <a:xfrm flipH="false" flipV="false" rot="0">
-              <a:off x="14304344" y="4575714"/>
-              <a:ext cx="380667" cy="380667"/>
-            </a:xfrm>
-            <a:custGeom>
-              <a:avLst/>
-              <a:gdLst/>
-              <a:ahLst/>
-              <a:cxnLst/>
-              <a:rect r="r" b="b" t="t" l="l"/>
-              <a:pathLst>
-                <a:path h="380667" w="380667">
-                  <a:moveTo>
-                    <a:pt x="0" y="0"/>
-                  </a:moveTo>
-                  <a:lnTo>
-                    <a:pt x="380667" y="0"/>
-                  </a:lnTo>
-                  <a:lnTo>
-                    <a:pt x="380667" y="380667"/>
-                  </a:lnTo>
-                  <a:lnTo>
-                    <a:pt x="0" y="380667"/>
-                  </a:lnTo>
-                  <a:lnTo>
-                    <a:pt x="0" y="0"/>
-                  </a:lnTo>
-                  <a:close/>
-                </a:path>
-              </a:pathLst>
-            </a:custGeom>
-            <a:blipFill>
-              <a:blip r:embed="rId11">
-                <a:extLst>
-                  <a:ext uri="{96DAC541-7B7A-43D3-8B79-37D633B846F1}">
-                    <asvg:svgBlip xmlns:asvg="http://schemas.microsoft.com/office/drawing/2016/SVG/main" r:embed="rId12"/>
-                  </a:ext>
-                </a:extLst>
-              </a:blip>
-              <a:stretch>
-                <a:fillRect l="0" t="0" r="0" b="0"/>
-              </a:stretch>
-            </a:blipFill>
-          </p:spPr>
-        </p:sp>
-        <p:sp>
-          <p:nvSpPr>
-            <p:cNvPr name="Freeform 26" id="26"/>
-            <p:cNvSpPr/>
-            <p:nvPr/>
-          </p:nvSpPr>
-          <p:spPr>
-            <a:xfrm flipH="false" flipV="false" rot="0">
-              <a:off x="14362454" y="885753"/>
-              <a:ext cx="380667" cy="380667"/>
-            </a:xfrm>
-            <a:custGeom>
-              <a:avLst/>
-              <a:gdLst/>
-              <a:ahLst/>
-              <a:cxnLst/>
-              <a:rect r="r" b="b" t="t" l="l"/>
-              <a:pathLst>
-                <a:path h="380667" w="380667">
-                  <a:moveTo>
-                    <a:pt x="0" y="0"/>
-                  </a:moveTo>
-                  <a:lnTo>
-                    <a:pt x="380666" y="0"/>
-                  </a:lnTo>
-                  <a:lnTo>
-                    <a:pt x="380666" y="380667"/>
-                  </a:lnTo>
-                  <a:lnTo>
-                    <a:pt x="0" y="380667"/>
-                  </a:lnTo>
-                  <a:lnTo>
-                    <a:pt x="0" y="0"/>
-                  </a:lnTo>
-                  <a:close/>
-                </a:path>
-              </a:pathLst>
-            </a:custGeom>
-            <a:blipFill>
-              <a:blip r:embed="rId11">
-                <a:extLst>
-                  <a:ext uri="{96DAC541-7B7A-43D3-8B79-37D633B846F1}">
-                    <asvg:svgBlip xmlns:asvg="http://schemas.microsoft.com/office/drawing/2016/SVG/main" r:embed="rId12"/>
-                  </a:ext>
-                </a:extLst>
-              </a:blip>
-              <a:stretch>
-                <a:fillRect l="0" t="0" r="0" b="0"/>
-              </a:stretch>
-            </a:blipFill>
-          </p:spPr>
-        </p:sp>
+      </p:grpSp>
+      <p:sp>
+        <p:nvSpPr>
+          <p:cNvPr name="Freeform 11" id="11"/>
+          <p:cNvSpPr/>
+          <p:nvPr/>
+        </p:nvSpPr>
+        <p:spPr>
+          <a:xfrm flipH="false" flipV="false" rot="0">
+            <a:off x="13129392" y="7016055"/>
+            <a:ext cx="285500" cy="285500"/>
+          </a:xfrm>
+          <a:custGeom>
+            <a:avLst/>
+            <a:gdLst/>
+            <a:ahLst/>
+            <a:cxnLst/>
+            <a:rect r="r" b="b" t="t" l="l"/>
+            <a:pathLst>
+              <a:path h="285500" w="285500">
+                <a:moveTo>
+                  <a:pt x="0" y="0"/>
+                </a:moveTo>
+                <a:lnTo>
+                  <a:pt x="285500" y="0"/>
+                </a:lnTo>
+                <a:lnTo>
+                  <a:pt x="285500" y="285500"/>
+                </a:lnTo>
+                <a:lnTo>
+                  <a:pt x="0" y="285500"/>
+                </a:lnTo>
+                <a:lnTo>
+                  <a:pt x="0" y="0"/>
+                </a:lnTo>
+                <a:close/>
+              </a:path>
+            </a:pathLst>
+          </a:custGeom>
+          <a:blipFill>
+            <a:blip r:embed="rId6">
+              <a:extLst>
+                <a:ext uri="{96DAC541-7B7A-43D3-8B79-37D633B846F1}">
+                  <asvg:svgBlip xmlns:asvg="http://schemas.microsoft.com/office/drawing/2016/SVG/main" r:embed="rId7"/>
+                </a:ext>
+              </a:extLst>
+            </a:blip>
+            <a:stretch>
+              <a:fillRect l="0" t="0" r="0" b="0"/>
+            </a:stretch>
+          </a:blipFill>
+        </p:spPr>
+      </p:sp>
+      <p:sp>
+        <p:nvSpPr>
+          <p:cNvPr name="Freeform 12" id="12"/>
+          <p:cNvSpPr/>
+          <p:nvPr/>
+        </p:nvSpPr>
+        <p:spPr>
+          <a:xfrm flipH="false" flipV="false" rot="0">
+            <a:off x="13114865" y="7938545"/>
+            <a:ext cx="285500" cy="285500"/>
+          </a:xfrm>
+          <a:custGeom>
+            <a:avLst/>
+            <a:gdLst/>
+            <a:ahLst/>
+            <a:cxnLst/>
+            <a:rect r="r" b="b" t="t" l="l"/>
+            <a:pathLst>
+              <a:path h="285500" w="285500">
+                <a:moveTo>
+                  <a:pt x="0" y="0"/>
+                </a:moveTo>
+                <a:lnTo>
+                  <a:pt x="285500" y="0"/>
+                </a:lnTo>
+                <a:lnTo>
+                  <a:pt x="285500" y="285500"/>
+                </a:lnTo>
+                <a:lnTo>
+                  <a:pt x="0" y="285500"/>
+                </a:lnTo>
+                <a:lnTo>
+                  <a:pt x="0" y="0"/>
+                </a:lnTo>
+                <a:close/>
+              </a:path>
+            </a:pathLst>
+          </a:custGeom>
+          <a:blipFill>
+            <a:blip r:embed="rId6">
+              <a:extLst>
+                <a:ext uri="{96DAC541-7B7A-43D3-8B79-37D633B846F1}">
+                  <asvg:svgBlip xmlns:asvg="http://schemas.microsoft.com/office/drawing/2016/SVG/main" r:embed="rId7"/>
+                </a:ext>
+              </a:extLst>
+            </a:blip>
+            <a:stretch>
+              <a:fillRect l="0" t="0" r="0" b="0"/>
+            </a:stretch>
+          </a:blipFill>
+        </p:spPr>
+      </p:sp>
+      <p:sp>
+        <p:nvSpPr>
+          <p:cNvPr name="Freeform 13" id="13"/>
+          <p:cNvSpPr/>
+          <p:nvPr/>
+        </p:nvSpPr>
+        <p:spPr>
+          <a:xfrm flipH="false" flipV="false" rot="0">
+            <a:off x="13100337" y="8861035"/>
+            <a:ext cx="285500" cy="285500"/>
+          </a:xfrm>
+          <a:custGeom>
+            <a:avLst/>
+            <a:gdLst/>
+            <a:ahLst/>
+            <a:cxnLst/>
+            <a:rect r="r" b="b" t="t" l="l"/>
+            <a:pathLst>
+              <a:path h="285500" w="285500">
+                <a:moveTo>
+                  <a:pt x="0" y="0"/>
+                </a:moveTo>
+                <a:lnTo>
+                  <a:pt x="285500" y="0"/>
+                </a:lnTo>
+                <a:lnTo>
+                  <a:pt x="285500" y="285500"/>
+                </a:lnTo>
+                <a:lnTo>
+                  <a:pt x="0" y="285500"/>
+                </a:lnTo>
+                <a:lnTo>
+                  <a:pt x="0" y="0"/>
+                </a:lnTo>
+                <a:close/>
+              </a:path>
+            </a:pathLst>
+          </a:custGeom>
+          <a:blipFill>
+            <a:blip r:embed="rId6">
+              <a:extLst>
+                <a:ext uri="{96DAC541-7B7A-43D3-8B79-37D633B846F1}">
+                  <asvg:svgBlip xmlns:asvg="http://schemas.microsoft.com/office/drawing/2016/SVG/main" r:embed="rId7"/>
+                </a:ext>
+              </a:extLst>
+            </a:blip>
+            <a:stretch>
+              <a:fillRect l="0" t="0" r="0" b="0"/>
+            </a:stretch>
+          </a:blipFill>
+        </p:spPr>
+      </p:sp>
+      <p:sp>
+        <p:nvSpPr>
+          <p:cNvPr name="Freeform 14" id="14"/>
+          <p:cNvSpPr/>
+          <p:nvPr/>
+        </p:nvSpPr>
+        <p:spPr>
+          <a:xfrm flipH="false" flipV="false" rot="0">
+            <a:off x="13143920" y="6093565"/>
+            <a:ext cx="285500" cy="285500"/>
+          </a:xfrm>
+          <a:custGeom>
+            <a:avLst/>
+            <a:gdLst/>
+            <a:ahLst/>
+            <a:cxnLst/>
+            <a:rect r="r" b="b" t="t" l="l"/>
+            <a:pathLst>
+              <a:path h="285500" w="285500">
+                <a:moveTo>
+                  <a:pt x="0" y="0"/>
+                </a:moveTo>
+                <a:lnTo>
+                  <a:pt x="285499" y="0"/>
+                </a:lnTo>
+                <a:lnTo>
+                  <a:pt x="285499" y="285500"/>
+                </a:lnTo>
+                <a:lnTo>
+                  <a:pt x="0" y="285500"/>
+                </a:lnTo>
+                <a:lnTo>
+                  <a:pt x="0" y="0"/>
+                </a:lnTo>
+                <a:close/>
+              </a:path>
+            </a:pathLst>
+          </a:custGeom>
+          <a:blipFill>
+            <a:blip r:embed="rId6">
+              <a:extLst>
+                <a:ext uri="{96DAC541-7B7A-43D3-8B79-37D633B846F1}">
+                  <asvg:svgBlip xmlns:asvg="http://schemas.microsoft.com/office/drawing/2016/SVG/main" r:embed="rId7"/>
+                </a:ext>
+              </a:extLst>
+            </a:blip>
+            <a:stretch>
+              <a:fillRect l="0" t="0" r="0" b="0"/>
+            </a:stretch>
+          </a:blipFill>
+        </p:spPr>
+      </p:sp>
+      <p:grpSp>
+        <p:nvGrpSpPr>
+          <p:cNvPr name="Group 15" id="15"/>
+          <p:cNvGrpSpPr/>
+          <p:nvPr/>
+        </p:nvGrpSpPr>
+        <p:grpSpPr>
+          <a:xfrm rot="0">
+            <a:off x="3469116" y="4441903"/>
+            <a:ext cx="10914590" cy="3588823"/>
+            <a:chOff x="0" y="0"/>
+            <a:chExt cx="14552787" cy="4785097"/>
+          </a:xfrm>
+        </p:grpSpPr>
         <p:grpSp>
           <p:nvGrpSpPr>
-            <p:cNvPr name="Group 27" id="27"/>
+            <p:cNvPr name="Group 16" id="16"/>
             <p:cNvGrpSpPr/>
             <p:nvPr/>
           </p:nvGrpSpPr>
@@ -4098,7 +3657,7 @@
           </p:grpSpPr>
           <p:sp>
             <p:nvSpPr>
-              <p:cNvPr name="Freeform 28" id="28"/>
+              <p:cNvPr name="Freeform 17" id="17"/>
               <p:cNvSpPr/>
               <p:nvPr/>
             </p:nvSpPr>
@@ -4176,7 +3735,7 @@
           </p:sp>
           <p:sp>
             <p:nvSpPr>
-              <p:cNvPr name="TextBox 29" id="29"/>
+              <p:cNvPr name="TextBox 18" id="18"/>
               <p:cNvSpPr txBox="true"/>
               <p:nvPr/>
             </p:nvSpPr>
@@ -4204,7 +3763,7 @@
         </p:grpSp>
         <p:grpSp>
           <p:nvGrpSpPr>
-            <p:cNvPr name="Group 30" id="30"/>
+            <p:cNvPr name="Group 19" id="19"/>
             <p:cNvGrpSpPr/>
             <p:nvPr/>
           </p:nvGrpSpPr>
@@ -4218,7 +3777,7 @@
           </p:grpSpPr>
           <p:sp>
             <p:nvSpPr>
-              <p:cNvPr name="Freeform 31" id="31"/>
+              <p:cNvPr name="Freeform 20" id="20"/>
               <p:cNvSpPr/>
               <p:nvPr/>
             </p:nvSpPr>
@@ -4296,7 +3855,7 @@
           </p:sp>
           <p:sp>
             <p:nvSpPr>
-              <p:cNvPr name="TextBox 32" id="32"/>
+              <p:cNvPr name="TextBox 21" id="21"/>
               <p:cNvSpPr txBox="true"/>
               <p:nvPr/>
             </p:nvSpPr>
@@ -4324,7 +3883,7 @@
         </p:grpSp>
         <p:grpSp>
           <p:nvGrpSpPr>
-            <p:cNvPr name="Group 33" id="33"/>
+            <p:cNvPr name="Group 22" id="22"/>
             <p:cNvGrpSpPr/>
             <p:nvPr/>
           </p:nvGrpSpPr>
@@ -4338,7 +3897,7 @@
           </p:grpSpPr>
           <p:sp>
             <p:nvSpPr>
-              <p:cNvPr name="Freeform 34" id="34"/>
+              <p:cNvPr name="Freeform 23" id="23"/>
               <p:cNvSpPr/>
               <p:nvPr/>
             </p:nvSpPr>
@@ -4416,7 +3975,7 @@
           </p:sp>
           <p:sp>
             <p:nvSpPr>
-              <p:cNvPr name="TextBox 35" id="35"/>
+              <p:cNvPr name="TextBox 24" id="24"/>
               <p:cNvSpPr txBox="true"/>
               <p:nvPr/>
             </p:nvSpPr>
@@ -4444,7 +4003,7 @@
         </p:grpSp>
         <p:grpSp>
           <p:nvGrpSpPr>
-            <p:cNvPr name="Group 36" id="36"/>
+            <p:cNvPr name="Group 25" id="25"/>
             <p:cNvGrpSpPr/>
             <p:nvPr/>
           </p:nvGrpSpPr>
@@ -4458,7 +4017,7 @@
           </p:grpSpPr>
           <p:sp>
             <p:nvSpPr>
-              <p:cNvPr name="Freeform 37" id="37"/>
+              <p:cNvPr name="Freeform 26" id="26"/>
               <p:cNvSpPr/>
               <p:nvPr/>
             </p:nvSpPr>
@@ -4536,7 +4095,7 @@
           </p:sp>
           <p:sp>
             <p:nvSpPr>
-              <p:cNvPr name="TextBox 38" id="38"/>
+              <p:cNvPr name="TextBox 27" id="27"/>
               <p:cNvSpPr txBox="true"/>
               <p:nvPr/>
             </p:nvSpPr>
@@ -4564,7 +4123,7 @@
         </p:grpSp>
         <p:sp>
           <p:nvSpPr>
-            <p:cNvPr name="AutoShape 39" id="39"/>
+            <p:cNvPr name="AutoShape 28" id="28"/>
             <p:cNvSpPr/>
             <p:nvPr/>
           </p:nvSpPr>
@@ -4588,7 +4147,7 @@
         </p:sp>
         <p:sp>
           <p:nvSpPr>
-            <p:cNvPr name="AutoShape 40" id="40"/>
+            <p:cNvPr name="AutoShape 29" id="29"/>
             <p:cNvSpPr/>
             <p:nvPr/>
           </p:nvSpPr>
@@ -4612,7 +4171,7 @@
         </p:sp>
         <p:sp>
           <p:nvSpPr>
-            <p:cNvPr name="AutoShape 41" id="41"/>
+            <p:cNvPr name="AutoShape 30" id="30"/>
             <p:cNvSpPr/>
             <p:nvPr/>
           </p:nvSpPr>
@@ -4636,7 +4195,7 @@
         </p:sp>
         <p:sp>
           <p:nvSpPr>
-            <p:cNvPr name="AutoShape 42" id="42"/>
+            <p:cNvPr name="AutoShape 31" id="31"/>
             <p:cNvSpPr/>
             <p:nvPr/>
           </p:nvSpPr>
@@ -4660,7 +4219,7 @@
         </p:sp>
         <p:sp>
           <p:nvSpPr>
-            <p:cNvPr name="TextBox 43" id="43"/>
+            <p:cNvPr name="TextBox 32" id="32"/>
             <p:cNvSpPr txBox="true"/>
             <p:nvPr/>
           </p:nvSpPr>
@@ -4685,7 +4244,7 @@
                 </a:lnSpc>
               </a:pPr>
               <a:r>
-                <a:rPr lang="en-US" sz="2700" b="true">
+                <a:rPr lang="en-US" b="true" sz="2700">
                   <a:solidFill>
                     <a:srgbClr val="2F0D8D"/>
                   </a:solidFill>
@@ -4701,7 +4260,7 @@
         </p:sp>
         <p:sp>
           <p:nvSpPr>
-            <p:cNvPr name="TextBox 44" id="44"/>
+            <p:cNvPr name="TextBox 33" id="33"/>
             <p:cNvSpPr txBox="true"/>
             <p:nvPr/>
           </p:nvSpPr>
@@ -4726,7 +4285,7 @@
                 </a:lnSpc>
               </a:pPr>
               <a:r>
-                <a:rPr lang="en-US" sz="2700" b="true">
+                <a:rPr lang="en-US" b="true" sz="2700">
                   <a:solidFill>
                     <a:srgbClr val="2F0D8D"/>
                   </a:solidFill>
@@ -4742,7 +4301,7 @@
         </p:sp>
         <p:sp>
           <p:nvSpPr>
-            <p:cNvPr name="TextBox 45" id="45"/>
+            <p:cNvPr name="TextBox 34" id="34"/>
             <p:cNvSpPr txBox="true"/>
             <p:nvPr/>
           </p:nvSpPr>
@@ -4767,7 +4326,7 @@
                 </a:lnSpc>
               </a:pPr>
               <a:r>
-                <a:rPr lang="en-US" sz="2700" b="true">
+                <a:rPr lang="en-US" b="true" sz="2700">
                   <a:solidFill>
                     <a:srgbClr val="2F0D8D"/>
                   </a:solidFill>
@@ -4783,7 +4342,7 @@
         </p:sp>
         <p:sp>
           <p:nvSpPr>
-            <p:cNvPr name="TextBox 46" id="46"/>
+            <p:cNvPr name="TextBox 35" id="35"/>
             <p:cNvSpPr txBox="true"/>
             <p:nvPr/>
           </p:nvSpPr>
@@ -4808,7 +4367,7 @@
                 </a:lnSpc>
               </a:pPr>
               <a:r>
-                <a:rPr lang="en-US" sz="2700" b="true">
+                <a:rPr lang="en-US" b="true" sz="2700">
                   <a:solidFill>
                     <a:srgbClr val="2F0D8D"/>
                   </a:solidFill>
@@ -4825,14 +4384,14 @@
       </p:grpSp>
       <p:sp>
         <p:nvSpPr>
-          <p:cNvPr name="TextBox 47" id="47"/>
+          <p:cNvPr name="TextBox 36" id="36"/>
           <p:cNvSpPr txBox="true"/>
           <p:nvPr/>
         </p:nvSpPr>
         <p:spPr>
           <a:xfrm rot="30000">
-            <a:off x="2378811" y="1744082"/>
-            <a:ext cx="5424934" cy="1566544"/>
+            <a:off x="3325738" y="1157269"/>
+            <a:ext cx="11450492" cy="1566544"/>
           </a:xfrm>
           <a:prstGeom prst="rect">
             <a:avLst/>
@@ -4890,13 +4449,180 @@
       </p:sp>
       <p:sp>
         <p:nvSpPr>
-          <p:cNvPr name="TextBox 48" id="48"/>
+          <p:cNvPr name="TextBox 37" id="37"/>
           <p:cNvSpPr txBox="true"/>
           <p:nvPr/>
         </p:nvSpPr>
         <p:spPr>
           <a:xfrm rot="0">
-            <a:off x="2838490" y="3895026"/>
+            <a:off x="1520008" y="286626"/>
+            <a:ext cx="3523222" cy="887101"/>
+          </a:xfrm>
+          <a:prstGeom prst="rect">
+            <a:avLst/>
+          </a:prstGeom>
+        </p:spPr>
+        <p:txBody>
+          <a:bodyPr anchor="t" rtlCol="false" tIns="0" lIns="0" bIns="0" rIns="0">
+            <a:spAutoFit/>
+          </a:bodyPr>
+          <a:lstStyle/>
+          <a:p>
+            <a:pPr algn="l">
+              <a:lnSpc>
+                <a:spcPts val="7279"/>
+              </a:lnSpc>
+            </a:pPr>
+            <a:r>
+              <a:rPr lang="en-US" sz="5199" i="true">
+                <a:solidFill>
+                  <a:srgbClr val="39ACA1"/>
+                </a:solidFill>
+                <a:latin typeface="Instrument Serif Italics"/>
+                <a:ea typeface="Instrument Serif Italics"/>
+                <a:cs typeface="Instrument Serif Italics"/>
+                <a:sym typeface="Instrument Serif Italics"/>
+              </a:rPr>
+              <a:t>Ignisia</a:t>
+            </a:r>
+          </a:p>
+        </p:txBody>
+      </p:sp>
+      <p:grpSp>
+        <p:nvGrpSpPr>
+          <p:cNvPr name="Group 38" id="38"/>
+          <p:cNvGrpSpPr/>
+          <p:nvPr/>
+        </p:nvGrpSpPr>
+        <p:grpSpPr>
+          <a:xfrm rot="0">
+            <a:off x="597445" y="291865"/>
+            <a:ext cx="923925" cy="981075"/>
+            <a:chOff x="0" y="0"/>
+            <a:chExt cx="1231900" cy="1308100"/>
+          </a:xfrm>
+        </p:grpSpPr>
+        <p:sp>
+          <p:nvSpPr>
+            <p:cNvPr name="Freeform 39" id="39"/>
+            <p:cNvSpPr/>
+            <p:nvPr/>
+          </p:nvSpPr>
+          <p:spPr>
+            <a:xfrm flipH="false" flipV="false" rot="0">
+              <a:off x="0" y="0"/>
+              <a:ext cx="1231900" cy="1308100"/>
+            </a:xfrm>
+            <a:custGeom>
+              <a:avLst/>
+              <a:gdLst/>
+              <a:ahLst/>
+              <a:cxnLst/>
+              <a:rect r="r" b="b" t="t" l="l"/>
+              <a:pathLst>
+                <a:path h="1308100" w="1231900">
+                  <a:moveTo>
+                    <a:pt x="0" y="0"/>
+                  </a:moveTo>
+                  <a:lnTo>
+                    <a:pt x="1231900" y="0"/>
+                  </a:lnTo>
+                  <a:lnTo>
+                    <a:pt x="1231900" y="1308100"/>
+                  </a:lnTo>
+                  <a:lnTo>
+                    <a:pt x="0" y="1308100"/>
+                  </a:lnTo>
+                  <a:lnTo>
+                    <a:pt x="0" y="0"/>
+                  </a:lnTo>
+                  <a:close/>
+                </a:path>
+              </a:pathLst>
+            </a:custGeom>
+            <a:blipFill>
+              <a:blip r:embed="rId8"/>
+              <a:stretch>
+                <a:fillRect l="-6188" t="0" r="-141234" b="0"/>
+              </a:stretch>
+            </a:blipFill>
+          </p:spPr>
+        </p:sp>
+      </p:grpSp>
+      <p:sp>
+        <p:nvSpPr>
+          <p:cNvPr name="TextBox 40" id="40"/>
+          <p:cNvSpPr txBox="true"/>
+          <p:nvPr/>
+        </p:nvSpPr>
+        <p:spPr>
+          <a:xfrm rot="0">
+            <a:off x="1874986" y="1109996"/>
+            <a:ext cx="966235" cy="151532"/>
+          </a:xfrm>
+          <a:prstGeom prst="rect">
+            <a:avLst/>
+          </a:prstGeom>
+        </p:spPr>
+        <p:txBody>
+          <a:bodyPr anchor="t" rtlCol="false" tIns="0" lIns="0" bIns="0" rIns="0">
+            <a:spAutoFit/>
+          </a:bodyPr>
+          <a:lstStyle/>
+          <a:p>
+            <a:pPr algn="l">
+              <a:lnSpc>
+                <a:spcPts val="1097"/>
+              </a:lnSpc>
+            </a:pPr>
+            <a:r>
+              <a:rPr lang="en-US" b="true" sz="784" i="true">
+                <a:solidFill>
+                  <a:srgbClr val="000000"/>
+                </a:solidFill>
+                <a:latin typeface="Calibri (MS) Bold Italics"/>
+                <a:ea typeface="Calibri (MS) Bold Italics"/>
+                <a:cs typeface="Calibri (MS) Bold Italics"/>
+                <a:sym typeface="Calibri (MS) Bold Italics"/>
+              </a:rPr>
+              <a:t>THINK. </a:t>
+            </a:r>
+            <a:r>
+              <a:rPr lang="en-US" b="true" sz="784" i="true">
+                <a:solidFill>
+                  <a:srgbClr val="39ACA1"/>
+                </a:solidFill>
+                <a:latin typeface="Calibri (MS) Bold Italics"/>
+                <a:ea typeface="Calibri (MS) Bold Italics"/>
+                <a:cs typeface="Calibri (MS) Bold Italics"/>
+                <a:sym typeface="Calibri (MS) Bold Italics"/>
+              </a:rPr>
+              <a:t>BUILD.</a:t>
+            </a:r>
+            <a:r>
+              <a:rPr lang="en-US" b="true" sz="784" i="true">
+                <a:solidFill>
+                  <a:srgbClr val="000000"/>
+                </a:solidFill>
+                <a:latin typeface="Calibri (MS) Bold Italics"/>
+                <a:ea typeface="Calibri (MS) Bold Italics"/>
+                <a:cs typeface="Calibri (MS) Bold Italics"/>
+                <a:sym typeface="Calibri (MS) Bold Italics"/>
+              </a:rPr>
+              <a:t> EVOLVE.</a:t>
+            </a:r>
+          </a:p>
+        </p:txBody>
+      </p:sp>
+      <p:sp>
+        <p:nvSpPr>
+          <p:cNvPr name="TextBox 41" id="41"/>
+          <p:cNvSpPr txBox="true"/>
+          <p:nvPr/>
+        </p:nvSpPr>
+        <p:spPr>
+          <a:xfrm rot="0">
+            <a:off x="6686846" y="3554795"/>
             <a:ext cx="4726781" cy="382284"/>
           </a:xfrm>
           <a:prstGeom prst="rect">
@@ -4929,6 +4655,540 @@
           </a:p>
         </p:txBody>
       </p:sp>
+      <p:grpSp>
+        <p:nvGrpSpPr>
+          <p:cNvPr name="Group 42" id="42"/>
+          <p:cNvGrpSpPr/>
+          <p:nvPr/>
+        </p:nvGrpSpPr>
+        <p:grpSpPr>
+          <a:xfrm rot="0">
+            <a:off x="2839185" y="8538370"/>
+            <a:ext cx="12666780" cy="1741589"/>
+            <a:chOff x="0" y="0"/>
+            <a:chExt cx="16889040" cy="2322119"/>
+          </a:xfrm>
+        </p:grpSpPr>
+        <p:sp>
+          <p:nvSpPr>
+            <p:cNvPr name="Freeform 43" id="43"/>
+            <p:cNvSpPr/>
+            <p:nvPr/>
+          </p:nvSpPr>
+          <p:spPr>
+            <a:xfrm flipH="false" flipV="false" rot="0">
+              <a:off x="5874065" y="458896"/>
+              <a:ext cx="2720777" cy="1510640"/>
+            </a:xfrm>
+            <a:custGeom>
+              <a:avLst/>
+              <a:gdLst/>
+              <a:ahLst/>
+              <a:cxnLst/>
+              <a:rect r="r" b="b" t="t" l="l"/>
+              <a:pathLst>
+                <a:path h="1510640" w="2720777">
+                  <a:moveTo>
+                    <a:pt x="0" y="0"/>
+                  </a:moveTo>
+                  <a:lnTo>
+                    <a:pt x="2720777" y="0"/>
+                  </a:lnTo>
+                  <a:lnTo>
+                    <a:pt x="2720777" y="1510640"/>
+                  </a:lnTo>
+                  <a:lnTo>
+                    <a:pt x="0" y="1510640"/>
+                  </a:lnTo>
+                  <a:lnTo>
+                    <a:pt x="0" y="0"/>
+                  </a:lnTo>
+                  <a:close/>
+                </a:path>
+              </a:pathLst>
+            </a:custGeom>
+            <a:blipFill>
+              <a:blip r:embed="rId9"/>
+              <a:stretch>
+                <a:fillRect l="0" t="0" r="0" b="0"/>
+              </a:stretch>
+            </a:blipFill>
+          </p:spPr>
+        </p:sp>
+        <p:sp>
+          <p:nvSpPr>
+            <p:cNvPr name="Freeform 44" id="44"/>
+            <p:cNvSpPr/>
+            <p:nvPr/>
+          </p:nvSpPr>
+          <p:spPr>
+            <a:xfrm flipH="false" flipV="false" rot="0">
+              <a:off x="2974120" y="800398"/>
+              <a:ext cx="1917690" cy="827635"/>
+            </a:xfrm>
+            <a:custGeom>
+              <a:avLst/>
+              <a:gdLst/>
+              <a:ahLst/>
+              <a:cxnLst/>
+              <a:rect r="r" b="b" t="t" l="l"/>
+              <a:pathLst>
+                <a:path h="827635" w="1917690">
+                  <a:moveTo>
+                    <a:pt x="0" y="0"/>
+                  </a:moveTo>
+                  <a:lnTo>
+                    <a:pt x="1917691" y="0"/>
+                  </a:lnTo>
+                  <a:lnTo>
+                    <a:pt x="1917691" y="827635"/>
+                  </a:lnTo>
+                  <a:lnTo>
+                    <a:pt x="0" y="827635"/>
+                  </a:lnTo>
+                  <a:lnTo>
+                    <a:pt x="0" y="0"/>
+                  </a:lnTo>
+                  <a:close/>
+                </a:path>
+              </a:pathLst>
+            </a:custGeom>
+            <a:blipFill>
+              <a:blip r:embed="rId10"/>
+              <a:stretch>
+                <a:fillRect l="0" t="0" r="0" b="0"/>
+              </a:stretch>
+            </a:blipFill>
+          </p:spPr>
+        </p:sp>
+        <p:sp>
+          <p:nvSpPr>
+            <p:cNvPr name="Freeform 45" id="45"/>
+            <p:cNvSpPr/>
+            <p:nvPr/>
+          </p:nvSpPr>
+          <p:spPr>
+            <a:xfrm flipH="false" flipV="false" rot="0">
+              <a:off x="15457558" y="751869"/>
+              <a:ext cx="958787" cy="829512"/>
+            </a:xfrm>
+            <a:custGeom>
+              <a:avLst/>
+              <a:gdLst/>
+              <a:ahLst/>
+              <a:cxnLst/>
+              <a:rect r="r" b="b" t="t" l="l"/>
+              <a:pathLst>
+                <a:path h="829512" w="958787">
+                  <a:moveTo>
+                    <a:pt x="0" y="0"/>
+                  </a:moveTo>
+                  <a:lnTo>
+                    <a:pt x="958787" y="0"/>
+                  </a:lnTo>
+                  <a:lnTo>
+                    <a:pt x="958787" y="829512"/>
+                  </a:lnTo>
+                  <a:lnTo>
+                    <a:pt x="0" y="829512"/>
+                  </a:lnTo>
+                  <a:lnTo>
+                    <a:pt x="0" y="0"/>
+                  </a:lnTo>
+                  <a:close/>
+                </a:path>
+              </a:pathLst>
+            </a:custGeom>
+            <a:blipFill>
+              <a:blip r:embed="rId11"/>
+              <a:stretch>
+                <a:fillRect l="0" t="0" r="0" b="0"/>
+              </a:stretch>
+            </a:blipFill>
+          </p:spPr>
+        </p:sp>
+        <p:sp>
+          <p:nvSpPr>
+            <p:cNvPr name="Freeform 46" id="46"/>
+            <p:cNvSpPr/>
+            <p:nvPr/>
+          </p:nvSpPr>
+          <p:spPr>
+            <a:xfrm flipH="false" flipV="false" rot="0">
+              <a:off x="10368290" y="702921"/>
+              <a:ext cx="2260785" cy="962483"/>
+            </a:xfrm>
+            <a:custGeom>
+              <a:avLst/>
+              <a:gdLst/>
+              <a:ahLst/>
+              <a:cxnLst/>
+              <a:rect r="r" b="b" t="t" l="l"/>
+              <a:pathLst>
+                <a:path h="962483" w="2260785">
+                  <a:moveTo>
+                    <a:pt x="0" y="0"/>
+                  </a:moveTo>
+                  <a:lnTo>
+                    <a:pt x="2260785" y="0"/>
+                  </a:lnTo>
+                  <a:lnTo>
+                    <a:pt x="2260785" y="962483"/>
+                  </a:lnTo>
+                  <a:lnTo>
+                    <a:pt x="0" y="962483"/>
+                  </a:lnTo>
+                  <a:lnTo>
+                    <a:pt x="0" y="0"/>
+                  </a:lnTo>
+                  <a:close/>
+                </a:path>
+              </a:pathLst>
+            </a:custGeom>
+            <a:blipFill>
+              <a:blip r:embed="rId12"/>
+              <a:stretch>
+                <a:fillRect l="0" t="-33158" r="0" b="-43061"/>
+              </a:stretch>
+            </a:blipFill>
+          </p:spPr>
+        </p:sp>
+        <p:sp>
+          <p:nvSpPr>
+            <p:cNvPr name="Freeform 47" id="47"/>
+            <p:cNvSpPr/>
+            <p:nvPr/>
+          </p:nvSpPr>
+          <p:spPr>
+            <a:xfrm flipH="false" flipV="false" rot="0">
+              <a:off x="0" y="0"/>
+              <a:ext cx="2322119" cy="2322119"/>
+            </a:xfrm>
+            <a:custGeom>
+              <a:avLst/>
+              <a:gdLst/>
+              <a:ahLst/>
+              <a:cxnLst/>
+              <a:rect r="r" b="b" t="t" l="l"/>
+              <a:pathLst>
+                <a:path h="2322119" w="2322119">
+                  <a:moveTo>
+                    <a:pt x="0" y="0"/>
+                  </a:moveTo>
+                  <a:lnTo>
+                    <a:pt x="2322119" y="0"/>
+                  </a:lnTo>
+                  <a:lnTo>
+                    <a:pt x="2322119" y="2322119"/>
+                  </a:lnTo>
+                  <a:lnTo>
+                    <a:pt x="0" y="2322119"/>
+                  </a:lnTo>
+                  <a:lnTo>
+                    <a:pt x="0" y="0"/>
+                  </a:lnTo>
+                  <a:close/>
+                </a:path>
+              </a:pathLst>
+            </a:custGeom>
+            <a:blipFill>
+              <a:blip r:embed="rId13"/>
+              <a:stretch>
+                <a:fillRect l="0" t="0" r="0" b="0"/>
+              </a:stretch>
+            </a:blipFill>
+          </p:spPr>
+        </p:sp>
+        <p:sp>
+          <p:nvSpPr>
+            <p:cNvPr name="AutoShape 48" id="48"/>
+            <p:cNvSpPr/>
+            <p:nvPr/>
+          </p:nvSpPr>
+          <p:spPr>
+            <a:xfrm flipV="true">
+              <a:off x="53951" y="702921"/>
+              <a:ext cx="0" cy="1014340"/>
+            </a:xfrm>
+            <a:prstGeom prst="line">
+              <a:avLst/>
+            </a:prstGeom>
+            <a:ln cap="flat" w="50800">
+              <a:solidFill>
+                <a:srgbClr val="B58FFF"/>
+              </a:solidFill>
+              <a:prstDash val="solid"/>
+              <a:headEnd type="none" len="sm" w="sm"/>
+              <a:tailEnd type="none" len="sm" w="sm"/>
+            </a:ln>
+          </p:spPr>
+        </p:sp>
+        <p:sp>
+          <p:nvSpPr>
+            <p:cNvPr name="AutoShape 49" id="49"/>
+            <p:cNvSpPr/>
+            <p:nvPr/>
+          </p:nvSpPr>
+          <p:spPr>
+            <a:xfrm flipV="true">
+              <a:off x="2500695" y="702921"/>
+              <a:ext cx="0" cy="1014340"/>
+            </a:xfrm>
+            <a:prstGeom prst="line">
+              <a:avLst/>
+            </a:prstGeom>
+            <a:ln cap="flat" w="50800">
+              <a:solidFill>
+                <a:srgbClr val="B58FFF"/>
+              </a:solidFill>
+              <a:prstDash val="solid"/>
+              <a:headEnd type="none" len="sm" w="sm"/>
+              <a:tailEnd type="none" len="sm" w="sm"/>
+            </a:ln>
+          </p:spPr>
+        </p:sp>
+        <p:sp>
+          <p:nvSpPr>
+            <p:cNvPr name="AutoShape 50" id="50"/>
+            <p:cNvSpPr/>
+            <p:nvPr/>
+          </p:nvSpPr>
+          <p:spPr>
+            <a:xfrm flipV="true">
+              <a:off x="5575373" y="702921"/>
+              <a:ext cx="0" cy="1014340"/>
+            </a:xfrm>
+            <a:prstGeom prst="line">
+              <a:avLst/>
+            </a:prstGeom>
+            <a:ln cap="flat" w="50800">
+              <a:solidFill>
+                <a:srgbClr val="B58FFF"/>
+              </a:solidFill>
+              <a:prstDash val="solid"/>
+              <a:headEnd type="none" len="sm" w="sm"/>
+              <a:tailEnd type="none" len="sm" w="sm"/>
+            </a:ln>
+          </p:spPr>
+        </p:sp>
+        <p:sp>
+          <p:nvSpPr>
+            <p:cNvPr name="AutoShape 51" id="51"/>
+            <p:cNvSpPr/>
+            <p:nvPr/>
+          </p:nvSpPr>
+          <p:spPr>
+            <a:xfrm flipV="true">
+              <a:off x="8676642" y="702921"/>
+              <a:ext cx="0" cy="1014340"/>
+            </a:xfrm>
+            <a:prstGeom prst="line">
+              <a:avLst/>
+            </a:prstGeom>
+            <a:ln cap="flat" w="50800">
+              <a:solidFill>
+                <a:srgbClr val="B58FFF"/>
+              </a:solidFill>
+              <a:prstDash val="solid"/>
+              <a:headEnd type="none" len="sm" w="sm"/>
+              <a:tailEnd type="none" len="sm" w="sm"/>
+            </a:ln>
+          </p:spPr>
+        </p:sp>
+        <p:sp>
+          <p:nvSpPr>
+            <p:cNvPr name="AutoShape 52" id="52"/>
+            <p:cNvSpPr/>
+            <p:nvPr/>
+          </p:nvSpPr>
+          <p:spPr>
+            <a:xfrm flipV="true">
+              <a:off x="10162290" y="702921"/>
+              <a:ext cx="0" cy="1014340"/>
+            </a:xfrm>
+            <a:prstGeom prst="line">
+              <a:avLst/>
+            </a:prstGeom>
+            <a:ln cap="flat" w="50800">
+              <a:solidFill>
+                <a:srgbClr val="B58FFF"/>
+              </a:solidFill>
+              <a:prstDash val="solid"/>
+              <a:headEnd type="none" len="sm" w="sm"/>
+              <a:tailEnd type="none" len="sm" w="sm"/>
+            </a:ln>
+          </p:spPr>
+        </p:sp>
+        <p:sp>
+          <p:nvSpPr>
+            <p:cNvPr name="Freeform 53" id="53"/>
+            <p:cNvSpPr/>
+            <p:nvPr/>
+          </p:nvSpPr>
+          <p:spPr>
+            <a:xfrm flipH="false" flipV="false" rot="0">
+              <a:off x="13431975" y="800398"/>
+              <a:ext cx="780983" cy="780983"/>
+            </a:xfrm>
+            <a:custGeom>
+              <a:avLst/>
+              <a:gdLst/>
+              <a:ahLst/>
+              <a:cxnLst/>
+              <a:rect r="r" b="b" t="t" l="l"/>
+              <a:pathLst>
+                <a:path h="780983" w="780983">
+                  <a:moveTo>
+                    <a:pt x="0" y="0"/>
+                  </a:moveTo>
+                  <a:lnTo>
+                    <a:pt x="780983" y="0"/>
+                  </a:lnTo>
+                  <a:lnTo>
+                    <a:pt x="780983" y="780983"/>
+                  </a:lnTo>
+                  <a:lnTo>
+                    <a:pt x="0" y="780983"/>
+                  </a:lnTo>
+                  <a:lnTo>
+                    <a:pt x="0" y="0"/>
+                  </a:lnTo>
+                  <a:close/>
+                </a:path>
+              </a:pathLst>
+            </a:custGeom>
+            <a:blipFill>
+              <a:blip r:embed="rId14"/>
+              <a:stretch>
+                <a:fillRect l="0" t="0" r="0" b="0"/>
+              </a:stretch>
+            </a:blipFill>
+            <a:ln cap="sq">
+              <a:noFill/>
+              <a:prstDash val="solid"/>
+              <a:miter/>
+            </a:ln>
+          </p:spPr>
+        </p:sp>
+        <p:sp>
+          <p:nvSpPr>
+            <p:cNvPr name="AutoShape 54" id="54"/>
+            <p:cNvSpPr/>
+            <p:nvPr/>
+          </p:nvSpPr>
+          <p:spPr>
+            <a:xfrm flipV="true">
+              <a:off x="12806875" y="747242"/>
+              <a:ext cx="0" cy="1014340"/>
+            </a:xfrm>
+            <a:prstGeom prst="line">
+              <a:avLst/>
+            </a:prstGeom>
+            <a:ln cap="flat" w="50800">
+              <a:solidFill>
+                <a:srgbClr val="B58FFF"/>
+              </a:solidFill>
+              <a:prstDash val="solid"/>
+              <a:headEnd type="none" len="sm" w="sm"/>
+              <a:tailEnd type="none" len="sm" w="sm"/>
+            </a:ln>
+          </p:spPr>
+        </p:sp>
+        <p:sp>
+          <p:nvSpPr>
+            <p:cNvPr name="Freeform 55" id="55"/>
+            <p:cNvSpPr/>
+            <p:nvPr/>
+          </p:nvSpPr>
+          <p:spPr>
+            <a:xfrm flipH="false" flipV="false" rot="0">
+              <a:off x="8952492" y="747242"/>
+              <a:ext cx="933948" cy="933948"/>
+            </a:xfrm>
+            <a:custGeom>
+              <a:avLst/>
+              <a:gdLst/>
+              <a:ahLst/>
+              <a:cxnLst/>
+              <a:rect r="r" b="b" t="t" l="l"/>
+              <a:pathLst>
+                <a:path h="933948" w="933948">
+                  <a:moveTo>
+                    <a:pt x="0" y="0"/>
+                  </a:moveTo>
+                  <a:lnTo>
+                    <a:pt x="933948" y="0"/>
+                  </a:lnTo>
+                  <a:lnTo>
+                    <a:pt x="933948" y="933948"/>
+                  </a:lnTo>
+                  <a:lnTo>
+                    <a:pt x="0" y="933948"/>
+                  </a:lnTo>
+                  <a:lnTo>
+                    <a:pt x="0" y="0"/>
+                  </a:lnTo>
+                  <a:close/>
+                </a:path>
+              </a:pathLst>
+            </a:custGeom>
+            <a:blipFill>
+              <a:blip r:embed="rId15"/>
+              <a:stretch>
+                <a:fillRect l="0" t="0" r="0" b="0"/>
+              </a:stretch>
+            </a:blipFill>
+          </p:spPr>
+        </p:sp>
+        <p:sp>
+          <p:nvSpPr>
+            <p:cNvPr name="AutoShape 56" id="56"/>
+            <p:cNvSpPr/>
+            <p:nvPr/>
+          </p:nvSpPr>
+          <p:spPr>
+            <a:xfrm flipV="true">
+              <a:off x="14835258" y="747242"/>
+              <a:ext cx="0" cy="1014340"/>
+            </a:xfrm>
+            <a:prstGeom prst="line">
+              <a:avLst/>
+            </a:prstGeom>
+            <a:ln cap="flat" w="50800">
+              <a:solidFill>
+                <a:srgbClr val="B58FFF"/>
+              </a:solidFill>
+              <a:prstDash val="solid"/>
+              <a:headEnd type="none" len="sm" w="sm"/>
+              <a:tailEnd type="none" len="sm" w="sm"/>
+            </a:ln>
+          </p:spPr>
+        </p:sp>
+        <p:sp>
+          <p:nvSpPr>
+            <p:cNvPr name="AutoShape 57" id="57"/>
+            <p:cNvSpPr/>
+            <p:nvPr/>
+          </p:nvSpPr>
+          <p:spPr>
+            <a:xfrm flipV="true">
+              <a:off x="16863640" y="702921"/>
+              <a:ext cx="0" cy="1014340"/>
+            </a:xfrm>
+            <a:prstGeom prst="line">
+              <a:avLst/>
+            </a:prstGeom>
+            <a:ln cap="flat" w="50800">
+              <a:solidFill>
+                <a:srgbClr val="B58FFF"/>
+              </a:solidFill>
+              <a:prstDash val="solid"/>
+              <a:headEnd type="none" len="sm" w="sm"/>
+              <a:tailEnd type="none" len="sm" w="sm"/>
+            </a:ln>
+          </p:spPr>
+        </p:sp>
+      </p:grpSp>
     </p:spTree>
   </p:cSld>
   <p:clrMapOvr>
@@ -5304,7 +5564,7 @@
         <p:spPr>
           <a:xfrm rot="0">
             <a:off x="1355260" y="480122"/>
-            <a:ext cx="13147408" cy="781036"/>
+            <a:ext cx="15678945" cy="781050"/>
           </a:xfrm>
           <a:prstGeom prst="rect">
             <a:avLst/>
@@ -6439,7 +6699,7 @@
         <p:spPr>
           <a:xfrm rot="0">
             <a:off x="1355260" y="480122"/>
-            <a:ext cx="7720410" cy="781050"/>
+            <a:ext cx="15205074" cy="781050"/>
           </a:xfrm>
           <a:prstGeom prst="rect">
             <a:avLst/>
@@ -7096,7 +7356,7 @@
         <p:spPr>
           <a:xfrm rot="0">
             <a:off x="1318244" y="625366"/>
-            <a:ext cx="12316662" cy="557389"/>
+            <a:ext cx="15705944" cy="557403"/>
           </a:xfrm>
           <a:prstGeom prst="rect">
             <a:avLst/>
@@ -8366,7 +8626,7 @@
         <p:spPr>
           <a:xfrm rot="0">
             <a:off x="1350077" y="413530"/>
-            <a:ext cx="7374636" cy="771511"/>
+            <a:ext cx="14667372" cy="771525"/>
           </a:xfrm>
           <a:prstGeom prst="rect">
             <a:avLst/>
@@ -9096,7 +9356,7 @@
         <p:spPr>
           <a:xfrm rot="0">
             <a:off x="1350077" y="413530"/>
-            <a:ext cx="11262568" cy="771511"/>
+            <a:ext cx="15181426" cy="771525"/>
           </a:xfrm>
           <a:prstGeom prst="rect">
             <a:avLst/>
@@ -9826,7 +10086,7 @@
         <p:spPr>
           <a:xfrm rot="0">
             <a:off x="1350077" y="413530"/>
-            <a:ext cx="6272887" cy="771511"/>
+            <a:ext cx="15381582" cy="771525"/>
           </a:xfrm>
           <a:prstGeom prst="rect">
             <a:avLst/>
@@ -10575,7 +10835,7 @@
         <p:spPr>
           <a:xfrm rot="0">
             <a:off x="1350077" y="413530"/>
-            <a:ext cx="8078008" cy="771511"/>
+            <a:ext cx="15633282" cy="771525"/>
           </a:xfrm>
           <a:prstGeom prst="rect">
             <a:avLst/>
@@ -11587,7 +11847,7 @@
         <p:spPr>
           <a:xfrm rot="0">
             <a:off x="1350077" y="413530"/>
-            <a:ext cx="8078008" cy="771511"/>
+            <a:ext cx="15562672" cy="771525"/>
           </a:xfrm>
           <a:prstGeom prst="rect">
             <a:avLst/>

</xml_diff>

<commit_message>
Poster, brochure and templates updated
</commit_message>
<xml_diff>
--- a/public/assets/Product_Track_Template.pptx
+++ b/public/assets/Product_Track_Template.pptx
@@ -4484,9 +4484,683 @@
           </p:spPr>
         </p:sp>
       </p:grpSp>
-      <p:sp>
-        <p:nvSpPr>
-          <p:cNvPr name="TextBox 39" id="39"/>
+      <p:grpSp>
+        <p:nvGrpSpPr>
+          <p:cNvPr name="Group 39" id="39"/>
+          <p:cNvGrpSpPr/>
+          <p:nvPr/>
+        </p:nvGrpSpPr>
+        <p:grpSpPr>
+          <a:xfrm rot="0">
+            <a:off x="1147601" y="8538370"/>
+            <a:ext cx="16011849" cy="1741589"/>
+            <a:chOff x="0" y="0"/>
+            <a:chExt cx="21349132" cy="2322119"/>
+          </a:xfrm>
+        </p:grpSpPr>
+        <p:sp>
+          <p:nvSpPr>
+            <p:cNvPr name="Freeform 40" id="40"/>
+            <p:cNvSpPr/>
+            <p:nvPr/>
+          </p:nvSpPr>
+          <p:spPr>
+            <a:xfrm flipH="false" flipV="false" rot="0">
+              <a:off x="5874065" y="458896"/>
+              <a:ext cx="2720777" cy="1510640"/>
+            </a:xfrm>
+            <a:custGeom>
+              <a:avLst/>
+              <a:gdLst/>
+              <a:ahLst/>
+              <a:cxnLst/>
+              <a:rect r="r" b="b" t="t" l="l"/>
+              <a:pathLst>
+                <a:path h="1510640" w="2720777">
+                  <a:moveTo>
+                    <a:pt x="0" y="0"/>
+                  </a:moveTo>
+                  <a:lnTo>
+                    <a:pt x="2720777" y="0"/>
+                  </a:lnTo>
+                  <a:lnTo>
+                    <a:pt x="2720777" y="1510640"/>
+                  </a:lnTo>
+                  <a:lnTo>
+                    <a:pt x="0" y="1510640"/>
+                  </a:lnTo>
+                  <a:lnTo>
+                    <a:pt x="0" y="0"/>
+                  </a:lnTo>
+                  <a:close/>
+                </a:path>
+              </a:pathLst>
+            </a:custGeom>
+            <a:blipFill>
+              <a:blip r:embed="rId9"/>
+              <a:stretch>
+                <a:fillRect l="0" t="0" r="0" b="0"/>
+              </a:stretch>
+            </a:blipFill>
+          </p:spPr>
+        </p:sp>
+        <p:sp>
+          <p:nvSpPr>
+            <p:cNvPr name="Freeform 41" id="41"/>
+            <p:cNvSpPr/>
+            <p:nvPr/>
+          </p:nvSpPr>
+          <p:spPr>
+            <a:xfrm flipH="false" flipV="false" rot="0">
+              <a:off x="2974120" y="800398"/>
+              <a:ext cx="1917690" cy="827635"/>
+            </a:xfrm>
+            <a:custGeom>
+              <a:avLst/>
+              <a:gdLst/>
+              <a:ahLst/>
+              <a:cxnLst/>
+              <a:rect r="r" b="b" t="t" l="l"/>
+              <a:pathLst>
+                <a:path h="827635" w="1917690">
+                  <a:moveTo>
+                    <a:pt x="0" y="0"/>
+                  </a:moveTo>
+                  <a:lnTo>
+                    <a:pt x="1917691" y="0"/>
+                  </a:lnTo>
+                  <a:lnTo>
+                    <a:pt x="1917691" y="827635"/>
+                  </a:lnTo>
+                  <a:lnTo>
+                    <a:pt x="0" y="827635"/>
+                  </a:lnTo>
+                  <a:lnTo>
+                    <a:pt x="0" y="0"/>
+                  </a:lnTo>
+                  <a:close/>
+                </a:path>
+              </a:pathLst>
+            </a:custGeom>
+            <a:blipFill>
+              <a:blip r:embed="rId10"/>
+              <a:stretch>
+                <a:fillRect l="0" t="0" r="0" b="0"/>
+              </a:stretch>
+            </a:blipFill>
+          </p:spPr>
+        </p:sp>
+        <p:sp>
+          <p:nvSpPr>
+            <p:cNvPr name="Freeform 42" id="42"/>
+            <p:cNvSpPr/>
+            <p:nvPr/>
+          </p:nvSpPr>
+          <p:spPr>
+            <a:xfrm flipH="false" flipV="false" rot="0">
+              <a:off x="15457558" y="751869"/>
+              <a:ext cx="958787" cy="829512"/>
+            </a:xfrm>
+            <a:custGeom>
+              <a:avLst/>
+              <a:gdLst/>
+              <a:ahLst/>
+              <a:cxnLst/>
+              <a:rect r="r" b="b" t="t" l="l"/>
+              <a:pathLst>
+                <a:path h="829512" w="958787">
+                  <a:moveTo>
+                    <a:pt x="0" y="0"/>
+                  </a:moveTo>
+                  <a:lnTo>
+                    <a:pt x="958787" y="0"/>
+                  </a:lnTo>
+                  <a:lnTo>
+                    <a:pt x="958787" y="829512"/>
+                  </a:lnTo>
+                  <a:lnTo>
+                    <a:pt x="0" y="829512"/>
+                  </a:lnTo>
+                  <a:lnTo>
+                    <a:pt x="0" y="0"/>
+                  </a:lnTo>
+                  <a:close/>
+                </a:path>
+              </a:pathLst>
+            </a:custGeom>
+            <a:blipFill>
+              <a:blip r:embed="rId11"/>
+              <a:stretch>
+                <a:fillRect l="0" t="0" r="0" b="0"/>
+              </a:stretch>
+            </a:blipFill>
+          </p:spPr>
+        </p:sp>
+        <p:sp>
+          <p:nvSpPr>
+            <p:cNvPr name="Freeform 43" id="43"/>
+            <p:cNvSpPr/>
+            <p:nvPr/>
+          </p:nvSpPr>
+          <p:spPr>
+            <a:xfrm flipH="false" flipV="false" rot="0">
+              <a:off x="10368290" y="702921"/>
+              <a:ext cx="2260785" cy="962483"/>
+            </a:xfrm>
+            <a:custGeom>
+              <a:avLst/>
+              <a:gdLst/>
+              <a:ahLst/>
+              <a:cxnLst/>
+              <a:rect r="r" b="b" t="t" l="l"/>
+              <a:pathLst>
+                <a:path h="962483" w="2260785">
+                  <a:moveTo>
+                    <a:pt x="0" y="0"/>
+                  </a:moveTo>
+                  <a:lnTo>
+                    <a:pt x="2260785" y="0"/>
+                  </a:lnTo>
+                  <a:lnTo>
+                    <a:pt x="2260785" y="962483"/>
+                  </a:lnTo>
+                  <a:lnTo>
+                    <a:pt x="0" y="962483"/>
+                  </a:lnTo>
+                  <a:lnTo>
+                    <a:pt x="0" y="0"/>
+                  </a:lnTo>
+                  <a:close/>
+                </a:path>
+              </a:pathLst>
+            </a:custGeom>
+            <a:blipFill>
+              <a:blip r:embed="rId12"/>
+              <a:stretch>
+                <a:fillRect l="0" t="-33158" r="0" b="-43061"/>
+              </a:stretch>
+            </a:blipFill>
+          </p:spPr>
+        </p:sp>
+        <p:sp>
+          <p:nvSpPr>
+            <p:cNvPr name="Freeform 44" id="44"/>
+            <p:cNvSpPr/>
+            <p:nvPr/>
+          </p:nvSpPr>
+          <p:spPr>
+            <a:xfrm flipH="false" flipV="false" rot="0">
+              <a:off x="0" y="0"/>
+              <a:ext cx="2322119" cy="2322119"/>
+            </a:xfrm>
+            <a:custGeom>
+              <a:avLst/>
+              <a:gdLst/>
+              <a:ahLst/>
+              <a:cxnLst/>
+              <a:rect r="r" b="b" t="t" l="l"/>
+              <a:pathLst>
+                <a:path h="2322119" w="2322119">
+                  <a:moveTo>
+                    <a:pt x="0" y="0"/>
+                  </a:moveTo>
+                  <a:lnTo>
+                    <a:pt x="2322119" y="0"/>
+                  </a:lnTo>
+                  <a:lnTo>
+                    <a:pt x="2322119" y="2322119"/>
+                  </a:lnTo>
+                  <a:lnTo>
+                    <a:pt x="0" y="2322119"/>
+                  </a:lnTo>
+                  <a:lnTo>
+                    <a:pt x="0" y="0"/>
+                  </a:lnTo>
+                  <a:close/>
+                </a:path>
+              </a:pathLst>
+            </a:custGeom>
+            <a:blipFill>
+              <a:blip r:embed="rId13"/>
+              <a:stretch>
+                <a:fillRect l="0" t="0" r="0" b="0"/>
+              </a:stretch>
+            </a:blipFill>
+          </p:spPr>
+        </p:sp>
+        <p:sp>
+          <p:nvSpPr>
+            <p:cNvPr name="AutoShape 45" id="45"/>
+            <p:cNvSpPr/>
+            <p:nvPr/>
+          </p:nvSpPr>
+          <p:spPr>
+            <a:xfrm flipV="true">
+              <a:off x="53951" y="702921"/>
+              <a:ext cx="0" cy="1014340"/>
+            </a:xfrm>
+            <a:prstGeom prst="line">
+              <a:avLst/>
+            </a:prstGeom>
+            <a:ln cap="flat" w="50800">
+              <a:solidFill>
+                <a:srgbClr val="B58FFF"/>
+              </a:solidFill>
+              <a:prstDash val="solid"/>
+              <a:headEnd type="none" len="sm" w="sm"/>
+              <a:tailEnd type="none" len="sm" w="sm"/>
+            </a:ln>
+          </p:spPr>
+        </p:sp>
+        <p:sp>
+          <p:nvSpPr>
+            <p:cNvPr name="AutoShape 46" id="46"/>
+            <p:cNvSpPr/>
+            <p:nvPr/>
+          </p:nvSpPr>
+          <p:spPr>
+            <a:xfrm flipV="true">
+              <a:off x="2500695" y="702921"/>
+              <a:ext cx="0" cy="1014340"/>
+            </a:xfrm>
+            <a:prstGeom prst="line">
+              <a:avLst/>
+            </a:prstGeom>
+            <a:ln cap="flat" w="50800">
+              <a:solidFill>
+                <a:srgbClr val="B58FFF"/>
+              </a:solidFill>
+              <a:prstDash val="solid"/>
+              <a:headEnd type="none" len="sm" w="sm"/>
+              <a:tailEnd type="none" len="sm" w="sm"/>
+            </a:ln>
+          </p:spPr>
+        </p:sp>
+        <p:sp>
+          <p:nvSpPr>
+            <p:cNvPr name="AutoShape 47" id="47"/>
+            <p:cNvSpPr/>
+            <p:nvPr/>
+          </p:nvSpPr>
+          <p:spPr>
+            <a:xfrm flipV="true">
+              <a:off x="5575373" y="702921"/>
+              <a:ext cx="0" cy="1014340"/>
+            </a:xfrm>
+            <a:prstGeom prst="line">
+              <a:avLst/>
+            </a:prstGeom>
+            <a:ln cap="flat" w="50800">
+              <a:solidFill>
+                <a:srgbClr val="B58FFF"/>
+              </a:solidFill>
+              <a:prstDash val="solid"/>
+              <a:headEnd type="none" len="sm" w="sm"/>
+              <a:tailEnd type="none" len="sm" w="sm"/>
+            </a:ln>
+          </p:spPr>
+        </p:sp>
+        <p:sp>
+          <p:nvSpPr>
+            <p:cNvPr name="AutoShape 48" id="48"/>
+            <p:cNvSpPr/>
+            <p:nvPr/>
+          </p:nvSpPr>
+          <p:spPr>
+            <a:xfrm flipV="true">
+              <a:off x="8676642" y="702921"/>
+              <a:ext cx="0" cy="1014340"/>
+            </a:xfrm>
+            <a:prstGeom prst="line">
+              <a:avLst/>
+            </a:prstGeom>
+            <a:ln cap="flat" w="50800">
+              <a:solidFill>
+                <a:srgbClr val="B58FFF"/>
+              </a:solidFill>
+              <a:prstDash val="solid"/>
+              <a:headEnd type="none" len="sm" w="sm"/>
+              <a:tailEnd type="none" len="sm" w="sm"/>
+            </a:ln>
+          </p:spPr>
+        </p:sp>
+        <p:sp>
+          <p:nvSpPr>
+            <p:cNvPr name="AutoShape 49" id="49"/>
+            <p:cNvSpPr/>
+            <p:nvPr/>
+          </p:nvSpPr>
+          <p:spPr>
+            <a:xfrm flipV="true">
+              <a:off x="10162290" y="702921"/>
+              <a:ext cx="0" cy="1014340"/>
+            </a:xfrm>
+            <a:prstGeom prst="line">
+              <a:avLst/>
+            </a:prstGeom>
+            <a:ln cap="flat" w="50800">
+              <a:solidFill>
+                <a:srgbClr val="B58FFF"/>
+              </a:solidFill>
+              <a:prstDash val="solid"/>
+              <a:headEnd type="none" len="sm" w="sm"/>
+              <a:tailEnd type="none" len="sm" w="sm"/>
+            </a:ln>
+          </p:spPr>
+        </p:sp>
+        <p:sp>
+          <p:nvSpPr>
+            <p:cNvPr name="Freeform 50" id="50"/>
+            <p:cNvSpPr/>
+            <p:nvPr/>
+          </p:nvSpPr>
+          <p:spPr>
+            <a:xfrm flipH="false" flipV="false" rot="0">
+              <a:off x="13431975" y="800398"/>
+              <a:ext cx="780983" cy="780983"/>
+            </a:xfrm>
+            <a:custGeom>
+              <a:avLst/>
+              <a:gdLst/>
+              <a:ahLst/>
+              <a:cxnLst/>
+              <a:rect r="r" b="b" t="t" l="l"/>
+              <a:pathLst>
+                <a:path h="780983" w="780983">
+                  <a:moveTo>
+                    <a:pt x="0" y="0"/>
+                  </a:moveTo>
+                  <a:lnTo>
+                    <a:pt x="780983" y="0"/>
+                  </a:lnTo>
+                  <a:lnTo>
+                    <a:pt x="780983" y="780983"/>
+                  </a:lnTo>
+                  <a:lnTo>
+                    <a:pt x="0" y="780983"/>
+                  </a:lnTo>
+                  <a:lnTo>
+                    <a:pt x="0" y="0"/>
+                  </a:lnTo>
+                  <a:close/>
+                </a:path>
+              </a:pathLst>
+            </a:custGeom>
+            <a:blipFill>
+              <a:blip r:embed="rId14"/>
+              <a:stretch>
+                <a:fillRect l="0" t="0" r="0" b="0"/>
+              </a:stretch>
+            </a:blipFill>
+            <a:ln cap="sq">
+              <a:noFill/>
+              <a:prstDash val="solid"/>
+              <a:miter/>
+            </a:ln>
+          </p:spPr>
+        </p:sp>
+        <p:sp>
+          <p:nvSpPr>
+            <p:cNvPr name="AutoShape 51" id="51"/>
+            <p:cNvSpPr/>
+            <p:nvPr/>
+          </p:nvSpPr>
+          <p:spPr>
+            <a:xfrm flipV="true">
+              <a:off x="12806875" y="747242"/>
+              <a:ext cx="0" cy="1014340"/>
+            </a:xfrm>
+            <a:prstGeom prst="line">
+              <a:avLst/>
+            </a:prstGeom>
+            <a:ln cap="flat" w="50800">
+              <a:solidFill>
+                <a:srgbClr val="B58FFF"/>
+              </a:solidFill>
+              <a:prstDash val="solid"/>
+              <a:headEnd type="none" len="sm" w="sm"/>
+              <a:tailEnd type="none" len="sm" w="sm"/>
+            </a:ln>
+          </p:spPr>
+        </p:sp>
+        <p:sp>
+          <p:nvSpPr>
+            <p:cNvPr name="Freeform 52" id="52"/>
+            <p:cNvSpPr/>
+            <p:nvPr/>
+          </p:nvSpPr>
+          <p:spPr>
+            <a:xfrm flipH="false" flipV="false" rot="0">
+              <a:off x="8952492" y="747242"/>
+              <a:ext cx="933948" cy="933948"/>
+            </a:xfrm>
+            <a:custGeom>
+              <a:avLst/>
+              <a:gdLst/>
+              <a:ahLst/>
+              <a:cxnLst/>
+              <a:rect r="r" b="b" t="t" l="l"/>
+              <a:pathLst>
+                <a:path h="933948" w="933948">
+                  <a:moveTo>
+                    <a:pt x="0" y="0"/>
+                  </a:moveTo>
+                  <a:lnTo>
+                    <a:pt x="933948" y="0"/>
+                  </a:lnTo>
+                  <a:lnTo>
+                    <a:pt x="933948" y="933948"/>
+                  </a:lnTo>
+                  <a:lnTo>
+                    <a:pt x="0" y="933948"/>
+                  </a:lnTo>
+                  <a:lnTo>
+                    <a:pt x="0" y="0"/>
+                  </a:lnTo>
+                  <a:close/>
+                </a:path>
+              </a:pathLst>
+            </a:custGeom>
+            <a:blipFill>
+              <a:blip r:embed="rId15"/>
+              <a:stretch>
+                <a:fillRect l="0" t="0" r="0" b="0"/>
+              </a:stretch>
+            </a:blipFill>
+          </p:spPr>
+        </p:sp>
+        <p:sp>
+          <p:nvSpPr>
+            <p:cNvPr name="AutoShape 53" id="53"/>
+            <p:cNvSpPr/>
+            <p:nvPr/>
+          </p:nvSpPr>
+          <p:spPr>
+            <a:xfrm flipV="true">
+              <a:off x="14835258" y="747242"/>
+              <a:ext cx="0" cy="1014340"/>
+            </a:xfrm>
+            <a:prstGeom prst="line">
+              <a:avLst/>
+            </a:prstGeom>
+            <a:ln cap="flat" w="50800">
+              <a:solidFill>
+                <a:srgbClr val="B58FFF"/>
+              </a:solidFill>
+              <a:prstDash val="solid"/>
+              <a:headEnd type="none" len="sm" w="sm"/>
+              <a:tailEnd type="none" len="sm" w="sm"/>
+            </a:ln>
+          </p:spPr>
+        </p:sp>
+        <p:sp>
+          <p:nvSpPr>
+            <p:cNvPr name="AutoShape 54" id="54"/>
+            <p:cNvSpPr/>
+            <p:nvPr/>
+          </p:nvSpPr>
+          <p:spPr>
+            <a:xfrm flipV="true">
+              <a:off x="16863640" y="702921"/>
+              <a:ext cx="0" cy="1014340"/>
+            </a:xfrm>
+            <a:prstGeom prst="line">
+              <a:avLst/>
+            </a:prstGeom>
+            <a:ln cap="flat" w="50800">
+              <a:solidFill>
+                <a:srgbClr val="B58FFF"/>
+              </a:solidFill>
+              <a:prstDash val="solid"/>
+              <a:headEnd type="none" len="sm" w="sm"/>
+              <a:tailEnd type="none" len="sm" w="sm"/>
+            </a:ln>
+          </p:spPr>
+        </p:sp>
+        <p:sp>
+          <p:nvSpPr>
+            <p:cNvPr name="Freeform 55" id="55"/>
+            <p:cNvSpPr/>
+            <p:nvPr/>
+          </p:nvSpPr>
+          <p:spPr>
+            <a:xfrm flipH="false" flipV="false" rot="0">
+              <a:off x="17106464" y="519332"/>
+              <a:ext cx="1207255" cy="1207255"/>
+            </a:xfrm>
+            <a:custGeom>
+              <a:avLst/>
+              <a:gdLst/>
+              <a:ahLst/>
+              <a:cxnLst/>
+              <a:rect r="r" b="b" t="t" l="l"/>
+              <a:pathLst>
+                <a:path h="1207255" w="1207255">
+                  <a:moveTo>
+                    <a:pt x="0" y="0"/>
+                  </a:moveTo>
+                  <a:lnTo>
+                    <a:pt x="1207255" y="0"/>
+                  </a:lnTo>
+                  <a:lnTo>
+                    <a:pt x="1207255" y="1207255"/>
+                  </a:lnTo>
+                  <a:lnTo>
+                    <a:pt x="0" y="1207255"/>
+                  </a:lnTo>
+                  <a:lnTo>
+                    <a:pt x="0" y="0"/>
+                  </a:lnTo>
+                  <a:close/>
+                </a:path>
+              </a:pathLst>
+            </a:custGeom>
+            <a:blipFill>
+              <a:blip r:embed="rId16"/>
+              <a:stretch>
+                <a:fillRect l="0" t="0" r="0" b="0"/>
+              </a:stretch>
+            </a:blipFill>
+          </p:spPr>
+        </p:sp>
+        <p:sp>
+          <p:nvSpPr>
+            <p:cNvPr name="AutoShape 56" id="56"/>
+            <p:cNvSpPr/>
+            <p:nvPr/>
+          </p:nvSpPr>
+          <p:spPr>
+            <a:xfrm flipV="true">
+              <a:off x="18618519" y="676993"/>
+              <a:ext cx="0" cy="1014340"/>
+            </a:xfrm>
+            <a:prstGeom prst="line">
+              <a:avLst/>
+            </a:prstGeom>
+            <a:ln cap="flat" w="50800">
+              <a:solidFill>
+                <a:srgbClr val="B58FFF"/>
+              </a:solidFill>
+              <a:prstDash val="solid"/>
+              <a:headEnd type="none" len="sm" w="sm"/>
+              <a:tailEnd type="none" len="sm" w="sm"/>
+            </a:ln>
+          </p:spPr>
+        </p:sp>
+        <p:sp>
+          <p:nvSpPr>
+            <p:cNvPr name="Freeform 57" id="57"/>
+            <p:cNvSpPr/>
+            <p:nvPr/>
+          </p:nvSpPr>
+          <p:spPr>
+            <a:xfrm flipH="false" flipV="false" rot="0">
+              <a:off x="19142496" y="972606"/>
+              <a:ext cx="1801531" cy="529035"/>
+            </a:xfrm>
+            <a:custGeom>
+              <a:avLst/>
+              <a:gdLst/>
+              <a:ahLst/>
+              <a:cxnLst/>
+              <a:rect r="r" b="b" t="t" l="l"/>
+              <a:pathLst>
+                <a:path h="529035" w="1801531">
+                  <a:moveTo>
+                    <a:pt x="0" y="0"/>
+                  </a:moveTo>
+                  <a:lnTo>
+                    <a:pt x="1801531" y="0"/>
+                  </a:lnTo>
+                  <a:lnTo>
+                    <a:pt x="1801531" y="529035"/>
+                  </a:lnTo>
+                  <a:lnTo>
+                    <a:pt x="0" y="529035"/>
+                  </a:lnTo>
+                  <a:lnTo>
+                    <a:pt x="0" y="0"/>
+                  </a:lnTo>
+                  <a:close/>
+                </a:path>
+              </a:pathLst>
+            </a:custGeom>
+            <a:blipFill>
+              <a:blip r:embed="rId17"/>
+              <a:stretch>
+                <a:fillRect l="0" t="0" r="0" b="0"/>
+              </a:stretch>
+            </a:blipFill>
+          </p:spPr>
+        </p:sp>
+        <p:sp>
+          <p:nvSpPr>
+            <p:cNvPr name="AutoShape 58" id="58"/>
+            <p:cNvSpPr/>
+            <p:nvPr/>
+          </p:nvSpPr>
+          <p:spPr>
+            <a:xfrm flipV="true">
+              <a:off x="21323732" y="653889"/>
+              <a:ext cx="0" cy="1014340"/>
+            </a:xfrm>
+            <a:prstGeom prst="line">
+              <a:avLst/>
+            </a:prstGeom>
+            <a:ln cap="flat" w="50800">
+              <a:solidFill>
+                <a:srgbClr val="B58FFF"/>
+              </a:solidFill>
+              <a:prstDash val="solid"/>
+              <a:headEnd type="none" len="sm" w="sm"/>
+              <a:tailEnd type="none" len="sm" w="sm"/>
+            </a:ln>
+          </p:spPr>
+        </p:sp>
+      </p:grpSp>
+      <p:sp>
+        <p:nvSpPr>
+          <p:cNvPr name="TextBox 59" id="59"/>
           <p:cNvSpPr txBox="true"/>
           <p:nvPr/>
         </p:nvSpPr>
@@ -4551,7 +5225,7 @@
       </p:sp>
       <p:sp>
         <p:nvSpPr>
-          <p:cNvPr name="TextBox 40" id="40"/>
+          <p:cNvPr name="TextBox 60" id="60"/>
           <p:cNvSpPr txBox="true"/>
           <p:nvPr/>
         </p:nvSpPr>
@@ -4616,7 +5290,7 @@
       </p:sp>
       <p:sp>
         <p:nvSpPr>
-          <p:cNvPr name="TextBox 41" id="41"/>
+          <p:cNvPr name="TextBox 61" id="61"/>
           <p:cNvSpPr txBox="true"/>
           <p:nvPr/>
         </p:nvSpPr>
@@ -4655,610 +5329,6 @@
           </a:p>
         </p:txBody>
       </p:sp>
-      <p:grpSp>
-        <p:nvGrpSpPr>
-          <p:cNvPr name="Group 42" id="42"/>
-          <p:cNvGrpSpPr/>
-          <p:nvPr/>
-        </p:nvGrpSpPr>
-        <p:grpSpPr>
-          <a:xfrm rot="0">
-            <a:off x="2291428" y="8538370"/>
-            <a:ext cx="13982939" cy="1741589"/>
-            <a:chOff x="0" y="0"/>
-            <a:chExt cx="18643919" cy="2322119"/>
-          </a:xfrm>
-        </p:grpSpPr>
-        <p:sp>
-          <p:nvSpPr>
-            <p:cNvPr name="Freeform 43" id="43"/>
-            <p:cNvSpPr/>
-            <p:nvPr/>
-          </p:nvSpPr>
-          <p:spPr>
-            <a:xfrm flipH="false" flipV="false" rot="0">
-              <a:off x="5874065" y="458896"/>
-              <a:ext cx="2720777" cy="1510640"/>
-            </a:xfrm>
-            <a:custGeom>
-              <a:avLst/>
-              <a:gdLst/>
-              <a:ahLst/>
-              <a:cxnLst/>
-              <a:rect r="r" b="b" t="t" l="l"/>
-              <a:pathLst>
-                <a:path h="1510640" w="2720777">
-                  <a:moveTo>
-                    <a:pt x="0" y="0"/>
-                  </a:moveTo>
-                  <a:lnTo>
-                    <a:pt x="2720777" y="0"/>
-                  </a:lnTo>
-                  <a:lnTo>
-                    <a:pt x="2720777" y="1510640"/>
-                  </a:lnTo>
-                  <a:lnTo>
-                    <a:pt x="0" y="1510640"/>
-                  </a:lnTo>
-                  <a:lnTo>
-                    <a:pt x="0" y="0"/>
-                  </a:lnTo>
-                  <a:close/>
-                </a:path>
-              </a:pathLst>
-            </a:custGeom>
-            <a:blipFill>
-              <a:blip r:embed="rId9"/>
-              <a:stretch>
-                <a:fillRect l="0" t="0" r="0" b="0"/>
-              </a:stretch>
-            </a:blipFill>
-          </p:spPr>
-        </p:sp>
-        <p:sp>
-          <p:nvSpPr>
-            <p:cNvPr name="Freeform 44" id="44"/>
-            <p:cNvSpPr/>
-            <p:nvPr/>
-          </p:nvSpPr>
-          <p:spPr>
-            <a:xfrm flipH="false" flipV="false" rot="0">
-              <a:off x="2974120" y="800398"/>
-              <a:ext cx="1917690" cy="827635"/>
-            </a:xfrm>
-            <a:custGeom>
-              <a:avLst/>
-              <a:gdLst/>
-              <a:ahLst/>
-              <a:cxnLst/>
-              <a:rect r="r" b="b" t="t" l="l"/>
-              <a:pathLst>
-                <a:path h="827635" w="1917690">
-                  <a:moveTo>
-                    <a:pt x="0" y="0"/>
-                  </a:moveTo>
-                  <a:lnTo>
-                    <a:pt x="1917691" y="0"/>
-                  </a:lnTo>
-                  <a:lnTo>
-                    <a:pt x="1917691" y="827635"/>
-                  </a:lnTo>
-                  <a:lnTo>
-                    <a:pt x="0" y="827635"/>
-                  </a:lnTo>
-                  <a:lnTo>
-                    <a:pt x="0" y="0"/>
-                  </a:lnTo>
-                  <a:close/>
-                </a:path>
-              </a:pathLst>
-            </a:custGeom>
-            <a:blipFill>
-              <a:blip r:embed="rId10"/>
-              <a:stretch>
-                <a:fillRect l="0" t="0" r="0" b="0"/>
-              </a:stretch>
-            </a:blipFill>
-          </p:spPr>
-        </p:sp>
-        <p:sp>
-          <p:nvSpPr>
-            <p:cNvPr name="Freeform 45" id="45"/>
-            <p:cNvSpPr/>
-            <p:nvPr/>
-          </p:nvSpPr>
-          <p:spPr>
-            <a:xfrm flipH="false" flipV="false" rot="0">
-              <a:off x="15457558" y="751869"/>
-              <a:ext cx="958787" cy="829512"/>
-            </a:xfrm>
-            <a:custGeom>
-              <a:avLst/>
-              <a:gdLst/>
-              <a:ahLst/>
-              <a:cxnLst/>
-              <a:rect r="r" b="b" t="t" l="l"/>
-              <a:pathLst>
-                <a:path h="829512" w="958787">
-                  <a:moveTo>
-                    <a:pt x="0" y="0"/>
-                  </a:moveTo>
-                  <a:lnTo>
-                    <a:pt x="958787" y="0"/>
-                  </a:lnTo>
-                  <a:lnTo>
-                    <a:pt x="958787" y="829512"/>
-                  </a:lnTo>
-                  <a:lnTo>
-                    <a:pt x="0" y="829512"/>
-                  </a:lnTo>
-                  <a:lnTo>
-                    <a:pt x="0" y="0"/>
-                  </a:lnTo>
-                  <a:close/>
-                </a:path>
-              </a:pathLst>
-            </a:custGeom>
-            <a:blipFill>
-              <a:blip r:embed="rId11"/>
-              <a:stretch>
-                <a:fillRect l="0" t="0" r="0" b="0"/>
-              </a:stretch>
-            </a:blipFill>
-          </p:spPr>
-        </p:sp>
-        <p:sp>
-          <p:nvSpPr>
-            <p:cNvPr name="Freeform 46" id="46"/>
-            <p:cNvSpPr/>
-            <p:nvPr/>
-          </p:nvSpPr>
-          <p:spPr>
-            <a:xfrm flipH="false" flipV="false" rot="0">
-              <a:off x="10368290" y="702921"/>
-              <a:ext cx="2260785" cy="962483"/>
-            </a:xfrm>
-            <a:custGeom>
-              <a:avLst/>
-              <a:gdLst/>
-              <a:ahLst/>
-              <a:cxnLst/>
-              <a:rect r="r" b="b" t="t" l="l"/>
-              <a:pathLst>
-                <a:path h="962483" w="2260785">
-                  <a:moveTo>
-                    <a:pt x="0" y="0"/>
-                  </a:moveTo>
-                  <a:lnTo>
-                    <a:pt x="2260785" y="0"/>
-                  </a:lnTo>
-                  <a:lnTo>
-                    <a:pt x="2260785" y="962483"/>
-                  </a:lnTo>
-                  <a:lnTo>
-                    <a:pt x="0" y="962483"/>
-                  </a:lnTo>
-                  <a:lnTo>
-                    <a:pt x="0" y="0"/>
-                  </a:lnTo>
-                  <a:close/>
-                </a:path>
-              </a:pathLst>
-            </a:custGeom>
-            <a:blipFill>
-              <a:blip r:embed="rId12"/>
-              <a:stretch>
-                <a:fillRect l="0" t="-33158" r="0" b="-43061"/>
-              </a:stretch>
-            </a:blipFill>
-          </p:spPr>
-        </p:sp>
-        <p:sp>
-          <p:nvSpPr>
-            <p:cNvPr name="Freeform 47" id="47"/>
-            <p:cNvSpPr/>
-            <p:nvPr/>
-          </p:nvSpPr>
-          <p:spPr>
-            <a:xfrm flipH="false" flipV="false" rot="0">
-              <a:off x="0" y="0"/>
-              <a:ext cx="2322119" cy="2322119"/>
-            </a:xfrm>
-            <a:custGeom>
-              <a:avLst/>
-              <a:gdLst/>
-              <a:ahLst/>
-              <a:cxnLst/>
-              <a:rect r="r" b="b" t="t" l="l"/>
-              <a:pathLst>
-                <a:path h="2322119" w="2322119">
-                  <a:moveTo>
-                    <a:pt x="0" y="0"/>
-                  </a:moveTo>
-                  <a:lnTo>
-                    <a:pt x="2322119" y="0"/>
-                  </a:lnTo>
-                  <a:lnTo>
-                    <a:pt x="2322119" y="2322119"/>
-                  </a:lnTo>
-                  <a:lnTo>
-                    <a:pt x="0" y="2322119"/>
-                  </a:lnTo>
-                  <a:lnTo>
-                    <a:pt x="0" y="0"/>
-                  </a:lnTo>
-                  <a:close/>
-                </a:path>
-              </a:pathLst>
-            </a:custGeom>
-            <a:blipFill>
-              <a:blip r:embed="rId13"/>
-              <a:stretch>
-                <a:fillRect l="0" t="0" r="0" b="0"/>
-              </a:stretch>
-            </a:blipFill>
-          </p:spPr>
-        </p:sp>
-        <p:sp>
-          <p:nvSpPr>
-            <p:cNvPr name="AutoShape 48" id="48"/>
-            <p:cNvSpPr/>
-            <p:nvPr/>
-          </p:nvSpPr>
-          <p:spPr>
-            <a:xfrm flipV="true">
-              <a:off x="53951" y="702921"/>
-              <a:ext cx="0" cy="1014340"/>
-            </a:xfrm>
-            <a:prstGeom prst="line">
-              <a:avLst/>
-            </a:prstGeom>
-            <a:ln cap="flat" w="50800">
-              <a:solidFill>
-                <a:srgbClr val="B58FFF"/>
-              </a:solidFill>
-              <a:prstDash val="solid"/>
-              <a:headEnd type="none" len="sm" w="sm"/>
-              <a:tailEnd type="none" len="sm" w="sm"/>
-            </a:ln>
-          </p:spPr>
-        </p:sp>
-        <p:sp>
-          <p:nvSpPr>
-            <p:cNvPr name="AutoShape 49" id="49"/>
-            <p:cNvSpPr/>
-            <p:nvPr/>
-          </p:nvSpPr>
-          <p:spPr>
-            <a:xfrm flipV="true">
-              <a:off x="2500695" y="702921"/>
-              <a:ext cx="0" cy="1014340"/>
-            </a:xfrm>
-            <a:prstGeom prst="line">
-              <a:avLst/>
-            </a:prstGeom>
-            <a:ln cap="flat" w="50800">
-              <a:solidFill>
-                <a:srgbClr val="B58FFF"/>
-              </a:solidFill>
-              <a:prstDash val="solid"/>
-              <a:headEnd type="none" len="sm" w="sm"/>
-              <a:tailEnd type="none" len="sm" w="sm"/>
-            </a:ln>
-          </p:spPr>
-        </p:sp>
-        <p:sp>
-          <p:nvSpPr>
-            <p:cNvPr name="AutoShape 50" id="50"/>
-            <p:cNvSpPr/>
-            <p:nvPr/>
-          </p:nvSpPr>
-          <p:spPr>
-            <a:xfrm flipV="true">
-              <a:off x="5575373" y="702921"/>
-              <a:ext cx="0" cy="1014340"/>
-            </a:xfrm>
-            <a:prstGeom prst="line">
-              <a:avLst/>
-            </a:prstGeom>
-            <a:ln cap="flat" w="50800">
-              <a:solidFill>
-                <a:srgbClr val="B58FFF"/>
-              </a:solidFill>
-              <a:prstDash val="solid"/>
-              <a:headEnd type="none" len="sm" w="sm"/>
-              <a:tailEnd type="none" len="sm" w="sm"/>
-            </a:ln>
-          </p:spPr>
-        </p:sp>
-        <p:sp>
-          <p:nvSpPr>
-            <p:cNvPr name="AutoShape 51" id="51"/>
-            <p:cNvSpPr/>
-            <p:nvPr/>
-          </p:nvSpPr>
-          <p:spPr>
-            <a:xfrm flipV="true">
-              <a:off x="8676642" y="702921"/>
-              <a:ext cx="0" cy="1014340"/>
-            </a:xfrm>
-            <a:prstGeom prst="line">
-              <a:avLst/>
-            </a:prstGeom>
-            <a:ln cap="flat" w="50800">
-              <a:solidFill>
-                <a:srgbClr val="B58FFF"/>
-              </a:solidFill>
-              <a:prstDash val="solid"/>
-              <a:headEnd type="none" len="sm" w="sm"/>
-              <a:tailEnd type="none" len="sm" w="sm"/>
-            </a:ln>
-          </p:spPr>
-        </p:sp>
-        <p:sp>
-          <p:nvSpPr>
-            <p:cNvPr name="AutoShape 52" id="52"/>
-            <p:cNvSpPr/>
-            <p:nvPr/>
-          </p:nvSpPr>
-          <p:spPr>
-            <a:xfrm flipV="true">
-              <a:off x="10162290" y="702921"/>
-              <a:ext cx="0" cy="1014340"/>
-            </a:xfrm>
-            <a:prstGeom prst="line">
-              <a:avLst/>
-            </a:prstGeom>
-            <a:ln cap="flat" w="50800">
-              <a:solidFill>
-                <a:srgbClr val="B58FFF"/>
-              </a:solidFill>
-              <a:prstDash val="solid"/>
-              <a:headEnd type="none" len="sm" w="sm"/>
-              <a:tailEnd type="none" len="sm" w="sm"/>
-            </a:ln>
-          </p:spPr>
-        </p:sp>
-        <p:sp>
-          <p:nvSpPr>
-            <p:cNvPr name="Freeform 53" id="53"/>
-            <p:cNvSpPr/>
-            <p:nvPr/>
-          </p:nvSpPr>
-          <p:spPr>
-            <a:xfrm flipH="false" flipV="false" rot="0">
-              <a:off x="13431975" y="800398"/>
-              <a:ext cx="780983" cy="780983"/>
-            </a:xfrm>
-            <a:custGeom>
-              <a:avLst/>
-              <a:gdLst/>
-              <a:ahLst/>
-              <a:cxnLst/>
-              <a:rect r="r" b="b" t="t" l="l"/>
-              <a:pathLst>
-                <a:path h="780983" w="780983">
-                  <a:moveTo>
-                    <a:pt x="0" y="0"/>
-                  </a:moveTo>
-                  <a:lnTo>
-                    <a:pt x="780983" y="0"/>
-                  </a:lnTo>
-                  <a:lnTo>
-                    <a:pt x="780983" y="780983"/>
-                  </a:lnTo>
-                  <a:lnTo>
-                    <a:pt x="0" y="780983"/>
-                  </a:lnTo>
-                  <a:lnTo>
-                    <a:pt x="0" y="0"/>
-                  </a:lnTo>
-                  <a:close/>
-                </a:path>
-              </a:pathLst>
-            </a:custGeom>
-            <a:blipFill>
-              <a:blip r:embed="rId14"/>
-              <a:stretch>
-                <a:fillRect l="0" t="0" r="0" b="0"/>
-              </a:stretch>
-            </a:blipFill>
-            <a:ln cap="sq">
-              <a:noFill/>
-              <a:prstDash val="solid"/>
-              <a:miter/>
-            </a:ln>
-          </p:spPr>
-        </p:sp>
-        <p:sp>
-          <p:nvSpPr>
-            <p:cNvPr name="AutoShape 54" id="54"/>
-            <p:cNvSpPr/>
-            <p:nvPr/>
-          </p:nvSpPr>
-          <p:spPr>
-            <a:xfrm flipV="true">
-              <a:off x="12806875" y="747242"/>
-              <a:ext cx="0" cy="1014340"/>
-            </a:xfrm>
-            <a:prstGeom prst="line">
-              <a:avLst/>
-            </a:prstGeom>
-            <a:ln cap="flat" w="50800">
-              <a:solidFill>
-                <a:srgbClr val="B58FFF"/>
-              </a:solidFill>
-              <a:prstDash val="solid"/>
-              <a:headEnd type="none" len="sm" w="sm"/>
-              <a:tailEnd type="none" len="sm" w="sm"/>
-            </a:ln>
-          </p:spPr>
-        </p:sp>
-        <p:sp>
-          <p:nvSpPr>
-            <p:cNvPr name="Freeform 55" id="55"/>
-            <p:cNvSpPr/>
-            <p:nvPr/>
-          </p:nvSpPr>
-          <p:spPr>
-            <a:xfrm flipH="false" flipV="false" rot="0">
-              <a:off x="8952492" y="747242"/>
-              <a:ext cx="933948" cy="933948"/>
-            </a:xfrm>
-            <a:custGeom>
-              <a:avLst/>
-              <a:gdLst/>
-              <a:ahLst/>
-              <a:cxnLst/>
-              <a:rect r="r" b="b" t="t" l="l"/>
-              <a:pathLst>
-                <a:path h="933948" w="933948">
-                  <a:moveTo>
-                    <a:pt x="0" y="0"/>
-                  </a:moveTo>
-                  <a:lnTo>
-                    <a:pt x="933948" y="0"/>
-                  </a:lnTo>
-                  <a:lnTo>
-                    <a:pt x="933948" y="933948"/>
-                  </a:lnTo>
-                  <a:lnTo>
-                    <a:pt x="0" y="933948"/>
-                  </a:lnTo>
-                  <a:lnTo>
-                    <a:pt x="0" y="0"/>
-                  </a:lnTo>
-                  <a:close/>
-                </a:path>
-              </a:pathLst>
-            </a:custGeom>
-            <a:blipFill>
-              <a:blip r:embed="rId15"/>
-              <a:stretch>
-                <a:fillRect l="0" t="0" r="0" b="0"/>
-              </a:stretch>
-            </a:blipFill>
-          </p:spPr>
-        </p:sp>
-        <p:sp>
-          <p:nvSpPr>
-            <p:cNvPr name="AutoShape 56" id="56"/>
-            <p:cNvSpPr/>
-            <p:nvPr/>
-          </p:nvSpPr>
-          <p:spPr>
-            <a:xfrm flipV="true">
-              <a:off x="14835258" y="747242"/>
-              <a:ext cx="0" cy="1014340"/>
-            </a:xfrm>
-            <a:prstGeom prst="line">
-              <a:avLst/>
-            </a:prstGeom>
-            <a:ln cap="flat" w="50800">
-              <a:solidFill>
-                <a:srgbClr val="B58FFF"/>
-              </a:solidFill>
-              <a:prstDash val="solid"/>
-              <a:headEnd type="none" len="sm" w="sm"/>
-              <a:tailEnd type="none" len="sm" w="sm"/>
-            </a:ln>
-          </p:spPr>
-        </p:sp>
-        <p:sp>
-          <p:nvSpPr>
-            <p:cNvPr name="AutoShape 57" id="57"/>
-            <p:cNvSpPr/>
-            <p:nvPr/>
-          </p:nvSpPr>
-          <p:spPr>
-            <a:xfrm flipV="true">
-              <a:off x="16863640" y="702921"/>
-              <a:ext cx="0" cy="1014340"/>
-            </a:xfrm>
-            <a:prstGeom prst="line">
-              <a:avLst/>
-            </a:prstGeom>
-            <a:ln cap="flat" w="50800">
-              <a:solidFill>
-                <a:srgbClr val="B58FFF"/>
-              </a:solidFill>
-              <a:prstDash val="solid"/>
-              <a:headEnd type="none" len="sm" w="sm"/>
-              <a:tailEnd type="none" len="sm" w="sm"/>
-            </a:ln>
-          </p:spPr>
-        </p:sp>
-        <p:sp>
-          <p:nvSpPr>
-            <p:cNvPr name="Freeform 58" id="58"/>
-            <p:cNvSpPr/>
-            <p:nvPr/>
-          </p:nvSpPr>
-          <p:spPr>
-            <a:xfrm flipH="false" flipV="false" rot="0">
-              <a:off x="17106464" y="519332"/>
-              <a:ext cx="1207255" cy="1207255"/>
-            </a:xfrm>
-            <a:custGeom>
-              <a:avLst/>
-              <a:gdLst/>
-              <a:ahLst/>
-              <a:cxnLst/>
-              <a:rect r="r" b="b" t="t" l="l"/>
-              <a:pathLst>
-                <a:path h="1207255" w="1207255">
-                  <a:moveTo>
-                    <a:pt x="0" y="0"/>
-                  </a:moveTo>
-                  <a:lnTo>
-                    <a:pt x="1207255" y="0"/>
-                  </a:lnTo>
-                  <a:lnTo>
-                    <a:pt x="1207255" y="1207255"/>
-                  </a:lnTo>
-                  <a:lnTo>
-                    <a:pt x="0" y="1207255"/>
-                  </a:lnTo>
-                  <a:lnTo>
-                    <a:pt x="0" y="0"/>
-                  </a:lnTo>
-                  <a:close/>
-                </a:path>
-              </a:pathLst>
-            </a:custGeom>
-            <a:blipFill>
-              <a:blip r:embed="rId16"/>
-              <a:stretch>
-                <a:fillRect l="0" t="0" r="0" b="0"/>
-              </a:stretch>
-            </a:blipFill>
-          </p:spPr>
-        </p:sp>
-        <p:sp>
-          <p:nvSpPr>
-            <p:cNvPr name="AutoShape 59" id="59"/>
-            <p:cNvSpPr/>
-            <p:nvPr/>
-          </p:nvSpPr>
-          <p:spPr>
-            <a:xfrm flipV="true">
-              <a:off x="18618519" y="676993"/>
-              <a:ext cx="0" cy="1014340"/>
-            </a:xfrm>
-            <a:prstGeom prst="line">
-              <a:avLst/>
-            </a:prstGeom>
-            <a:ln cap="flat" w="50800">
-              <a:solidFill>
-                <a:srgbClr val="B58FFF"/>
-              </a:solidFill>
-              <a:prstDash val="solid"/>
-              <a:headEnd type="none" len="sm" w="sm"/>
-              <a:tailEnd type="none" len="sm" w="sm"/>
-            </a:ln>
-          </p:spPr>
-        </p:sp>
-      </p:grpSp>
     </p:spTree>
   </p:cSld>
   <p:clrMapOvr>

</xml_diff>